<commit_message>
Clarify The Pile Japanese and explain corpus composition and language-model use
</commit_message>
<xml_diff>
--- a/slides/datasets-in-10-minutes-the-pile.pptx
+++ b/slides/datasets-in-10-minutes-the-pile.pptx
@@ -55,9 +55,7 @@
     <p:sldId id="303" r:id="rId53"/>
     <p:sldId id="304" r:id="rId54"/>
     <p:sldId id="305" r:id="rId55"/>
-    <p:sldId id="306" r:id="rId56"/>
     <p:sldId id="307" r:id="rId57"/>
-    <p:sldId id="308" r:id="rId58"/>
     <p:sldId id="309" r:id="rId59"/>
     <p:sldId id="310" r:id="rId60"/>
     <p:sldId id="311" r:id="rId61"/>
@@ -8115,7 +8113,7 @@
                           <a:ea typeface="Noto Sans CJK JP"/>
                           <a:cs typeface="Noto Sans"/>
                         </a:rPr>
-                        <a:t>平均文書サイズ</a:t>
+                        <a:t>文書の平均長</a:t>
                       </a:r>
                     </a:p>
                   </a:txBody>
@@ -8300,7 +8298,7 @@
                 <a:ea typeface="Noto Sans CJK JP"/>
                 <a:cs typeface="Noto Sans"/>
               </a:rPr>
-              <a:t>いずれも保留集合を作る前の値。GiBは2³⁰ byte。重みは混合後のバイト比率である。</a:t>
+              <a:t>いずれも検証・テスト用の文書を取り分ける前の値。GiBは2³⁰ byte。重みは混合後のバイト比率である。</a:t>
             </a:r>
           </a:p>
         </p:txBody>
@@ -8526,7 +8524,7 @@
                 <a:ea typeface="Noto Sans CJK JP"/>
                 <a:cs typeface="Noto Sans"/>
               </a:rPr>
-              <a:t>ArXivではLaTeXからテキストを作り、PubMed Centralでは論文全文を取り込む。特許は背景説明、NIHは研究助成の要約と、必要な部分を選ぶ。</a:t>
+              <a:t>ArXivではLaTeXからテキストを作り、PubMed Centralでは論文全文を取り込む。特許は背景説明、NIHは研究助成の要約と、出所に合わせて収録部分を選ぶ。</a:t>
             </a:r>
           </a:p>
           <a:p>
@@ -8556,7 +8554,7 @@
                 <a:ea typeface="Noto Sans CJK JP"/>
                 <a:cs typeface="Noto Sans"/>
               </a:rPr>
-              <a:t>注釈者が正解ラベルを付ける方式ではない。構成要素別の抽出、フィルタ、整形の後に反復回数を設定し、文書を混合・シャッフルする。</a:t>
+              <a:t>構成要素ごとに抽出・フィルタ・整形し、反復回数を設定した後、文書を混合・シャッフルする。</a:t>
             </a:r>
           </a:p>
         </p:txBody>
@@ -10278,7 +10276,7 @@
                 <a:ea typeface="Noto Sans CJK JP"/>
                 <a:cs typeface="Noto Sans"/>
               </a:rPr>
-              <a:t>文書単位の保留集合で分野別に評価する</a:t>
+              <a:t>検証・テスト文書で分野別に評価する</a:t>
             </a:r>
           </a:p>
         </p:txBody>
@@ -10331,7 +10329,7 @@
                 <a:ea typeface="Noto Sans CJK JP"/>
                 <a:cs typeface="Noto Sans"/>
               </a:rPr>
-              <a:t>混合用の文書から検証・テスト用の文書を取り分ける。データはJSON Lines形式で、各行にtextとmeta.pile_set_nameが含まれる。</a:t>
+              <a:t>混合用の文書から検証・テスト用の文書を取り分ける。データは1行1文書のJSON Lines形式で、本文と構成要素名が含まれる。</a:t>
             </a:r>
           </a:p>
           <a:p>
@@ -10391,7 +10389,7 @@
                 <a:ea typeface="Noto Sans CJK JP"/>
                 <a:cs typeface="Noto Sans"/>
               </a:rPr>
-              <a:t>長い文書をどう窓に分けるか、学習データの重複をどう除くかが評価結果に関わる。元のPileと重複除去版は、別の学習条件として区別する。</a:t>
+              <a:t>長文の分割方法や、学習文との重複は評価結果に関わる。後には、元のPileから重複文書を除いたバージョンも作られた。</a:t>
             </a:r>
           </a:p>
         </p:txBody>
@@ -12035,7 +12033,7 @@
                 <a:ea typeface="Noto Sans CJK JP"/>
                 <a:cs typeface="Noto Sans"/>
               </a:rPr>
-              <a:t>同じ1.3Bモデルを各データの約40 GBで学習。評価集合との13-gram重複を除去。LAMBADAは末尾の単語を当てる正解率。</a:t>
+              <a:t>同じ1.3Bモデルを各データの約40 GBで学習。評価集合と重複する学習データを除去。LAMBADAは末尾の単語を当てる正解率。</a:t>
             </a:r>
           </a:p>
         </p:txBody>
@@ -12178,7 +12176,7 @@
                 <a:ea typeface="Noto Sans CJK JP"/>
                 <a:cs typeface="Noto Sans"/>
               </a:rPr>
-              <a:t>HELMは6分野のテスト本文を使う</a:t>
+              <a:t>HELMでは6分野の文章の予測しやすさを測る</a:t>
             </a:r>
           </a:p>
         </p:txBody>
@@ -12231,7 +12229,7 @@
                 <a:ea typeface="Noto Sans CJK JP"/>
                 <a:cs typeface="Noto Sans"/>
               </a:rPr>
-              <a:t>HELM Classic v0.4.0の公開run仕様では、ArXiv、BookCorpus2、Enron Emails、Github、PubMed Central、Wikipedia (en)の6構成要素を評価する。</a:t>
+              <a:t>HELM Classic v0.4.0では、ArXiv、BookCorpus2、Enron Emails、Github、PubMed Central、Wikipedia (en)の6構成要素を評価する。</a:t>
             </a:r>
           </a:p>
           <a:p>
@@ -12261,37 +12259,7 @@
                 <a:ea typeface="Noto Sans CJK JP"/>
                 <a:cs typeface="Noto Sans"/>
               </a:rPr>
-              <a:t>テスト集合の構成要素別文書を読み、lm_perplexityのgroup0の索引で部分抽出する。BookCorpus2は文書数が少ないため、この10分割を行わない。</a:t>
-            </a:r>
-          </a:p>
-          <a:p>
-            <a:pPr marL="457200" indent="-355600">
-              <a:lnSpc>
-                <a:spcPts val="2379"/>
-              </a:lnSpc>
-              <a:spcAft>
-                <a:spcPts val="0"/>
-              </a:spcAft>
-              <a:buSzPct val="66500"/>
-              <a:buFont typeface="Noto Sans CJK JP"/>
-              <a:buChar char="●"/>
-              <a:defRPr sz="2000" b="0">
-                <a:solidFill>
-                  <a:srgbClr val="303437"/>
-                </a:solidFill>
-                <a:latin typeface="Noto Sans"/>
-              </a:defRPr>
-            </a:pPr>
-            <a:r>
-              <a:rPr sz="2000" b="0" lang="ja-JP" altLang="en-US">
-                <a:solidFill>
-                  <a:srgbClr val="303437"/>
-                </a:solidFill>
-                <a:latin typeface="Noto Sans"/>
-                <a:ea typeface="Noto Sans CJK JP"/>
-                <a:cs typeface="Noto Sans"/>
-              </a:rPr>
-              <a:t>採点はlanguage_modeling方式。学習例は0、試行は1、最大評価文書数は1,000。生成する回答はなく、max_tokensは0に設定される。</a:t>
+              <a:t>テスト文書から分野ごとに評価対象を選び、本文に与える確率を採点する。</a:t>
             </a:r>
           </a:p>
         </p:txBody>
@@ -13466,7 +13434,7 @@
                 <a:ea typeface="Noto Sans CJK JP"/>
                 <a:cs typeface="Noto Sans"/>
               </a:rPr>
-              <a:t>Classic v0.4.0掲載、元run suite v0.3.0。各1試行。ArXivは238文書、他は各1,000文書。モデル別の文脈長・分割条件を含む結果。</a:t>
+              <a:t>HELM Classicで2023年に公開された結果。各1試行でArXivは238文書、他は各1,000文書。モデルごとの文脈長で本文を分割して採点した。</a:t>
             </a:r>
           </a:p>
         </p:txBody>
@@ -13908,37 +13876,7 @@
                 <a:ea typeface="Noto Sans CJK JP"/>
                 <a:cs typeface="Noto Sans"/>
               </a:rPr>
-              <a:t>これは2023年のHELM Classic公開実行の比較である。2026年時点のモデル順位を示す値ではない。</a:t>
-            </a:r>
-          </a:p>
-          <a:p>
-            <a:pPr marL="457200" indent="-355600">
-              <a:lnSpc>
-                <a:spcPts val="2379"/>
-              </a:lnSpc>
-              <a:spcAft>
-                <a:spcPts val="0"/>
-              </a:spcAft>
-              <a:buSzPct val="66500"/>
-              <a:buFont typeface="Noto Sans CJK JP"/>
-              <a:buChar char="●"/>
-              <a:defRPr sz="2000" b="0">
-                <a:solidFill>
-                  <a:srgbClr val="303437"/>
-                </a:solidFill>
-                <a:latin typeface="Noto Sans"/>
-              </a:defRPr>
-            </a:pPr>
-            <a:r>
-              <a:rPr sz="2000" b="0" lang="ja-JP" altLang="en-US">
-                <a:solidFill>
-                  <a:srgbClr val="303437"/>
-                </a:solidFill>
-                <a:latin typeface="Noto Sans"/>
-                <a:ea typeface="Noto Sans CJK JP"/>
-                <a:cs typeface="Noto Sans"/>
-              </a:rPr>
-              <a:t>同じテスト文書でもモデルの文脈窓とトークン化が異なる。今回の9実行のprompt_truncated平均はいずれも0だが、長文はアダプター内で複数の窓へ分割される。</a:t>
+              <a:t>同じテスト文書でも、モデルによってトークンの切り方や使える文脈長が異なる。長文を複数の窓に分けて採点するため、得点には文章の分野に加えて、こうした評価条件も影響する。</a:t>
             </a:r>
           </a:p>
         </p:txBody>
@@ -14377,7 +14315,7 @@
                 <a:ea typeface="Noto Sans CJK JP"/>
                 <a:cs typeface="Noto Sans"/>
               </a:rPr>
-              <a:t>標準Pile版に加え、約207Bトークンの重複除去版を使う系列も公開した。同じ約300Bトークンは、標準版で1周弱、重複除去版で約1.5周に当たる。</a:t>
+              <a:t>標準Pile版に加え、約207Bトークンの重複除去版を使う系列も公開した。約300Bトークンの学習は、標準版で1周弱、重複除去版で約1.5周に当たる。</a:t>
             </a:r>
           </a:p>
           <a:p>
@@ -14407,7 +14345,7 @@
                 <a:ea typeface="Noto Sans CJK JP"/>
                 <a:cs typeface="Noto Sans"/>
               </a:rPr>
-              <a:t>学習途中のチェックポイントとデータ順を対応させ、知識の獲得、記憶、学習規模の影響を調べる。公式リポジトリは2025年の派生研究も案内している。</a:t>
+              <a:t>学習途中のチェックポイントとデータ順を公開し、知識の獲得や記憶、モデル規模が学習に与える影響を調べる基盤になった。</a:t>
             </a:r>
           </a:p>
         </p:txBody>
@@ -14649,7 +14587,7 @@
                 <a:ea typeface="Noto Sans CJK JP"/>
                 <a:cs typeface="Noto Sans"/>
               </a:rPr>
-              <a:t>再構築コードと本文の権利を分けて確認する</a:t>
+              <a:t>構成要素ごとに、本文の利用条件が異なる</a:t>
             </a:r>
           </a:p>
         </p:txBody>
@@ -14702,7 +14640,7 @@
                 <a:ea typeface="Noto Sans CJK JP"/>
                 <a:cs typeface="Noto Sans"/>
               </a:rPr>
-              <a:t>公式GitHubは再構築・変種作成のコードを提供し、READMEから配布先を案内している。コードのMIT Licenseは、収録本文すべての利用許諾を意味しない。</a:t>
+              <a:t>公式GitHubは再構築・変種作成のコードをMIT Licenseで提供する。収録本文の権利は、22の出所ごとに異なる。</a:t>
             </a:r>
           </a:p>
           <a:p>
@@ -14732,7 +14670,7 @@
                 <a:ea typeface="Noto Sans CJK JP"/>
                 <a:cs typeface="Noto Sans"/>
               </a:rPr>
-              <a:t>本文の出所は22通りあり、著作権、ライセンス、利用規約、本人の同意の扱いが異なる。書籍、字幕、コード、公開メールを一つの条件で扱うことはできない。</a:t>
+              <a:t>書籍、字幕、コード、公開メールなどには、それぞれの著作権、ライセンス、利用規約、本人の同意に関わる条件がある。</a:t>
             </a:r>
           </a:p>
           <a:p>
@@ -14762,7 +14700,7 @@
                 <a:ea typeface="Noto Sans CJK JP"/>
                 <a:cs typeface="Noto Sans"/>
               </a:rPr>
-              <a:t>特定の構成要素を除いた変種を作れるが、個別文書の権利を精密に判定できるメタデータは不足している。データカードと各元資料の条件を組み合わせて確認する。</a:t>
+              <a:t>特定の構成要素を除いたバージョンも作れるが、個別文書の権利を判定するためのメタデータは不足している。データカードと元資料の条件を確かめる必要がある。</a:t>
             </a:r>
           </a:p>
         </p:txBody>
@@ -15004,7 +14942,7 @@
                 <a:ea typeface="Noto Sans CJK JP"/>
                 <a:cs typeface="Noto Sans"/>
               </a:rPr>
-              <a:t>入手時には構成要素と分割を固定する</a:t>
+              <a:t>公式コードと公開サンプルから内容を調べられる</a:t>
             </a:r>
           </a:p>
         </p:txBody>
@@ -15057,7 +14995,7 @@
                 <a:ea typeface="Noto Sans CJK JP"/>
                 <a:cs typeface="Noto Sans"/>
               </a:rPr>
-              <a:t>再現する対象が元のPileか、重複除去版か、構成要素を除いた変種かを決める。学習・検証・テストの分割とファイルのハッシュを保存する。</a:t>
+              <a:t>公式リポジトリから、構成要素の収集コードや配布先をたどれる。再構築では、どの構成要素を何回使うかを設定する。</a:t>
             </a:r>
           </a:p>
           <a:p>
@@ -15087,7 +15025,7 @@
                 <a:ea typeface="Noto Sans CJK JP"/>
                 <a:cs typeface="Noto Sans"/>
               </a:rPr>
-              <a:t>HELM v0.4.0の実装はthe-eye.euのtest.jsonl.zstと、lm_perplexityの索引を参照する。配布URLや権利条件は取得時に再確認する。</a:t>
+              <a:t>内容を小さく試すには、先頭10,000文書を収めた公開サンプルpile-10kが使える。本資料の13例も、このサンプルから選んだ連続した抜粋である。</a:t>
             </a:r>
           </a:p>
           <a:p>
@@ -15117,7 +15055,7 @@
                 <a:ea typeface="Noto Sans CJK JP"/>
                 <a:cs typeface="Noto Sans"/>
               </a:rPr>
-              <a:t>本資料の13例は、公開pile-10kの先頭100行だけを取得したもの。原文・連続した表示範囲・訳・行番号・ハッシュは付属のexamples.jsonに保存した。</a:t>
+              <a:t>HELMの言語モデリング評価には、元のPileのテスト集合を使う。標準版・重複除去版・構成要素を除いたバージョンでは、収録文書や学習条件が変わる。</a:t>
             </a:r>
           </a:p>
         </p:txBody>
@@ -15442,7 +15380,7 @@
                 <a:ea typeface="Noto Sans CJK JP"/>
                 <a:cs typeface="Noto Sans"/>
               </a:rPr>
-              <a:t>約40 GBにそろえた実験でも、Webだけの学習より幅広い分野の予測損失が改善した。HELMはその一部を、分野別の本文尤度評価に用いている。</a:t>
+              <a:t>約40 GBにそろえた実験でも、Webだけの学習より幅広い分野の予測損失が改善した。HELMでは一部の構成要素を使い、本文に与える確率を分野別に評価している。</a:t>
             </a:r>
           </a:p>
           <a:p>
@@ -15472,7 +15410,7 @@
                 <a:ea typeface="Noto Sans CJK JP"/>
                 <a:cs typeface="Noto Sans"/>
               </a:rPr>
-              <a:t>文書の種類、混合比、重複除去、評価時の文脈窓、出所ごとの利用条件を対応させると、得点と研究利用の意味を具体的に把握できる。</a:t>
+              <a:t>多様な文章を混ぜる設計は、学習後の性能比較だけでなく、Pythiaのように学習過程を調べる研究にも使われている。</a:t>
             </a:r>
           </a:p>
         </p:txBody>
@@ -15633,11 +15571,11 @@
         <p:spPr>
           <a:xfrm>
             <a:off x="548640" y="2484835"/>
-            <a:ext cx="8046720" cy="585216"/>
+            <a:ext cx="8046720" cy="686816"/>
           </a:xfrm>
         </p:spPr>
         <p:txBody>
-          <a:bodyPr wrap="square" lIns="0" rIns="0" tIns="0" bIns="0" anchor="ctr">
+          <a:bodyPr wrap="square" lIns="0" rIns="0" tIns="0" bIns="101600" anchor="ctr">
             <a:noAutofit/>
           </a:bodyPr>
           <a:lstStyle/>
@@ -15890,7 +15828,7 @@
                 <a:ea typeface="Noto Sans CJK JP"/>
                 <a:cs typeface="Noto Sans"/>
               </a:rPr>
-              <a:t>制作機関と参考文献</a:t>
+              <a:t>参考文献</a:t>
             </a:r>
           </a:p>
         </p:txBody>
@@ -16106,7 +16044,7 @@
                 <a:ea typeface="Noto Sans CJK JP"/>
                 <a:cs typeface="Noto Sans"/>
               </a:rPr>
-              <a:t>公開10kサンプル / row 2 / 全文1235字からの連続抜粋</a:t>
+              <a:t>公開サンプルの本文から抜粋</a:t>
             </a:r>
           </a:p>
         </p:txBody>
@@ -16711,7 +16649,7 @@
                 <a:ea typeface="Noto Sans CJK JP"/>
                 <a:cs typeface="Noto Sans"/>
               </a:rPr>
-              <a:t>公開10kサンプル / row 5 / 全文2016字からの連続抜粋</a:t>
+              <a:t>公開サンプルの本文から抜粋</a:t>
             </a:r>
           </a:p>
         </p:txBody>
@@ -17573,7 +17511,7 @@
                 <a:ea typeface="Noto Sans CJK JP"/>
                 <a:cs typeface="Noto Sans"/>
               </a:rPr>
-              <a:t>公開10kサンプル / row 10 / 全文2665字からの連続抜粋</a:t>
+              <a:t>公開サンプルの本文から抜粋</a:t>
             </a:r>
           </a:p>
         </p:txBody>
@@ -18178,7 +18116,7 @@
                 <a:ea typeface="Noto Sans CJK JP"/>
                 <a:cs typeface="Noto Sans"/>
               </a:rPr>
-              <a:t>公開10kサンプル / row 18 / 全文1711字からの連続抜粋</a:t>
+              <a:t>公開サンプルの本文から抜粋</a:t>
             </a:r>
           </a:p>
         </p:txBody>
@@ -18659,7 +18597,7 @@
                 <a:ea typeface="Noto Sans CJK JP"/>
                 <a:cs typeface="Noto Sans"/>
               </a:rPr>
-              <a:t>公開10kサンプル / row 54 / 全文12919字からの連続抜粋</a:t>
+              <a:t>公開サンプルの本文から抜粋</a:t>
             </a:r>
           </a:p>
         </p:txBody>
@@ -19326,7 +19264,7 @@
                 <a:ea typeface="Noto Sans CJK JP"/>
                 <a:cs typeface="Noto Sans"/>
               </a:rPr>
-              <a:t>公開10kサンプル / row 55 / 全文362字からの連続抜粋</a:t>
+              <a:t>公開サンプルの本文から抜粋</a:t>
             </a:r>
           </a:p>
         </p:txBody>
@@ -19694,7 +19632,7 @@
                 <a:ea typeface="Noto Sans CJK JP"/>
                 <a:cs typeface="Noto Sans"/>
               </a:rPr>
-              <a:t>これは長文の情報・文書提供依頼です。どのように対応を完結させるのが最善か、ご意見をください。</a:t>
+              <a:t>これは長文の情報・文書提供依頼です。この依頼への対応をどのように完了させるのがよいか、ご意見をください。</a:t>
             </a:r>
           </a:p>
           <a:p>
@@ -19841,7 +19779,7 @@
                 <a:ea typeface="Noto Sans CJK JP"/>
                 <a:cs typeface="Noto Sans"/>
               </a:rPr>
-              <a:t>Enron Emailsは公開された業務メール。ここでは本文だけを抜粋する。</a:t>
+              <a:t>Enron Emailsには、公開された企業の業務メールが収められている。</a:t>
             </a:r>
           </a:p>
         </p:txBody>
@@ -20086,7 +20024,7 @@
                 <a:ea typeface="Noto Sans CJK JP"/>
                 <a:cs typeface="Noto Sans"/>
               </a:rPr>
-              <a:t>公開10kサンプル / row 63 / 全文2867字からの連続抜粋</a:t>
+              <a:t>公開サンプルの本文から抜粋</a:t>
             </a:r>
           </a:p>
         </p:txBody>
@@ -20691,7 +20629,7 @@
                 <a:ea typeface="Noto Sans CJK JP"/>
                 <a:cs typeface="Noto Sans"/>
               </a:rPr>
-              <a:t>公開10kサンプル / row 70 / 全文155字からの連続抜粋</a:t>
+              <a:t>公開サンプルの本文から抜粋</a:t>
             </a:r>
           </a:p>
         </p:txBody>
@@ -21420,7 +21358,7 @@
                 <a:ea typeface="Noto Sans CJK JP"/>
                 <a:cs typeface="Noto Sans"/>
               </a:rPr>
-              <a:t>公開10kサンプル / row 74 / 全文4010字からの連続抜粋</a:t>
+              <a:t>公開サンプルの本文から抜粋</a:t>
             </a:r>
           </a:p>
         </p:txBody>
@@ -21602,7 +21540,7 @@
                 <a:ea typeface="Noto Sans CJK JP"/>
                 <a:cs typeface="Noto Sans"/>
               </a:rPr>
-              <a:t>常染色体優性多発性嚢胞腎（ADPKD）は、進行する嚢胞形成に関連する一般的な単一アレル性疾患であり、60歳までに患者の50%が末期腎不全（ESRD）に至る。</a:t>
+              <a:t>常染色体優性多発性嚢胞腎（ADPKD）は、進行する嚢胞形成に関連する比較的よくみられる単一アレル性疾患であり、60歳までに患者の50%が末期腎不全（ESRD）に至る。</a:t>
             </a:r>
           </a:p>
         </p:txBody>
@@ -21901,7 +21839,7 @@
                 <a:ea typeface="Noto Sans CJK JP"/>
                 <a:cs typeface="Noto Sans"/>
               </a:rPr>
-              <a:t>公開10kサンプル / row 36 / 全文358字からの連続抜粋</a:t>
+              <a:t>公開サンプルの本文から抜粋</a:t>
             </a:r>
           </a:p>
         </p:txBody>
@@ -22207,7 +22145,7 @@
                 <a:ea typeface="Noto Sans CJK JP"/>
                 <a:cs typeface="Noto Sans"/>
               </a:rPr>
-              <a:t>前年優勝者はLaura PigossiとNadia Podoroskaだったが、ともに出場しなかった。</a:t>
+              <a:t>前年優勝者はLaura PigossiとNadia Podoroskaだったが、ともに出場を見送った。</a:t>
             </a:r>
           </a:p>
         </p:txBody>
@@ -34028,7 +33966,7 @@
                 <a:ea typeface="Noto Sans CJK JP"/>
                 <a:cs typeface="Noto Sans"/>
               </a:rPr>
-              <a:t>[1] Gao et al. (2020). The Pile: An 800GB Dataset of Diverse Text for Language Modeling. 構築者の整理：○は該当、—は該当すると判断されていない。</a:t>
+              <a:t>[1] Gao et al. (2020). The Pile: An 800GB Dataset of Diverse Text for Language Modeling.</a:t>
             </a:r>
           </a:p>
           <a:p>
@@ -34055,6 +33993,40 @@
                 <a:hlinkClick r:id="rId2"/>
               </a:rPr>
               <a:t>https://arxiv.org/abs/2101.00027</a:t>
+            </a:r>
+          </a:p>
+        </p:txBody>
+      </p:sp>
+      <p:sp>
+        <p:nvSpPr>
+          <p:cNvPr id="6" name="TextBox 5"/>
+          <p:cNvSpPr txBox="1"/>
+          <p:nvPr/>
+        </p:nvSpPr>
+        <p:spPr>
+          <a:xfrm>
+            <a:off x="594360" y="4305300"/>
+            <a:ext cx="7955280" cy="317500"/>
+          </a:xfrm>
+          <a:prstGeom prst="rect">
+            <a:avLst/>
+          </a:prstGeom>
+          <a:noFill/>
+        </p:spPr>
+        <p:txBody>
+          <a:bodyPr wrap="none">
+            <a:spAutoFit/>
+          </a:bodyPr>
+          <a:lstStyle/>
+          <a:p>
+            <a:r>
+              <a:rPr sz="1200">
+                <a:solidFill>
+                  <a:srgbClr val="303638"/>
+                </a:solidFill>
+                <a:latin typeface="Noto Sans CJK JP"/>
+              </a:rPr>
+              <a:t>2020年の構築者による分類。○は該当、—は該当すると判断されていない。</a:t>
             </a:r>
           </a:p>
         </p:txBody>
@@ -35710,7 +35682,7 @@
                 <a:ea typeface="Noto Sans CJK JP"/>
                 <a:cs typeface="Noto Sans"/>
               </a:rPr>
-              <a:t>[1] Gao et al. (2020). The Pile: An 800GB Dataset of Diverse Text for Language Modeling. 構築者の整理：○は該当、—は該当すると判断されていない。</a:t>
+              <a:t>[1] Gao et al. (2020). The Pile: An 800GB Dataset of Diverse Text for Language Modeling.</a:t>
             </a:r>
           </a:p>
           <a:p>
@@ -35737,6 +35709,40 @@
                 <a:hlinkClick r:id="rId2"/>
               </a:rPr>
               <a:t>https://arxiv.org/abs/2101.00027</a:t>
+            </a:r>
+          </a:p>
+        </p:txBody>
+      </p:sp>
+      <p:sp>
+        <p:nvSpPr>
+          <p:cNvPr id="6" name="TextBox 5"/>
+          <p:cNvSpPr txBox="1"/>
+          <p:nvPr/>
+        </p:nvSpPr>
+        <p:spPr>
+          <a:xfrm>
+            <a:off x="594360" y="4305300"/>
+            <a:ext cx="7955280" cy="317500"/>
+          </a:xfrm>
+          <a:prstGeom prst="rect">
+            <a:avLst/>
+          </a:prstGeom>
+          <a:noFill/>
+        </p:spPr>
+        <p:txBody>
+          <a:bodyPr wrap="none">
+            <a:spAutoFit/>
+          </a:bodyPr>
+          <a:lstStyle/>
+          <a:p>
+            <a:r>
+              <a:rPr sz="1200">
+                <a:solidFill>
+                  <a:srgbClr val="303638"/>
+                </a:solidFill>
+                <a:latin typeface="Noto Sans CJK JP"/>
+              </a:rPr>
+              <a:t>2020年の構築者による分類。○は該当、—は該当すると判断されていない。</a:t>
             </a:r>
           </a:p>
         </p:txBody>
@@ -37392,7 +37398,7 @@
                 <a:ea typeface="Noto Sans CJK JP"/>
                 <a:cs typeface="Noto Sans"/>
               </a:rPr>
-              <a:t>[1] Gao et al. (2020). The Pile: An 800GB Dataset of Diverse Text for Language Modeling. 構築者の整理：○は該当、—は該当すると判断されていない。</a:t>
+              <a:t>[1] Gao et al. (2020). The Pile: An 800GB Dataset of Diverse Text for Language Modeling.</a:t>
             </a:r>
           </a:p>
           <a:p>
@@ -37419,6 +37425,40 @@
                 <a:hlinkClick r:id="rId2"/>
               </a:rPr>
               <a:t>https://arxiv.org/abs/2101.00027</a:t>
+            </a:r>
+          </a:p>
+        </p:txBody>
+      </p:sp>
+      <p:sp>
+        <p:nvSpPr>
+          <p:cNvPr id="6" name="TextBox 5"/>
+          <p:cNvSpPr txBox="1"/>
+          <p:nvPr/>
+        </p:nvSpPr>
+        <p:spPr>
+          <a:xfrm>
+            <a:off x="594360" y="4305300"/>
+            <a:ext cx="7955280" cy="317500"/>
+          </a:xfrm>
+          <a:prstGeom prst="rect">
+            <a:avLst/>
+          </a:prstGeom>
+          <a:noFill/>
+        </p:spPr>
+        <p:txBody>
+          <a:bodyPr wrap="none">
+            <a:spAutoFit/>
+          </a:bodyPr>
+          <a:lstStyle/>
+          <a:p>
+            <a:r>
+              <a:rPr sz="1200">
+                <a:solidFill>
+                  <a:srgbClr val="303638"/>
+                </a:solidFill>
+                <a:latin typeface="Noto Sans CJK JP"/>
+              </a:rPr>
+              <a:t>2020年の構築者による分類。○は該当、—は該当すると判断されていない。</a:t>
             </a:r>
           </a:p>
         </p:txBody>
@@ -38670,7 +38710,7 @@
                 <a:ea typeface="Noto Sans CJK JP"/>
                 <a:cs typeface="Noto Sans"/>
               </a:rPr>
-              <a:t>[1] Gao et al. (2020). The Pile: An 800GB Dataset of Diverse Text for Language Modeling. 構築者の整理：○は該当、—は該当すると判断されていない。</a:t>
+              <a:t>[1] Gao et al. (2020). The Pile: An 800GB Dataset of Diverse Text for Language Modeling.</a:t>
             </a:r>
           </a:p>
           <a:p>
@@ -38697,6 +38737,40 @@
                 <a:hlinkClick r:id="rId2"/>
               </a:rPr>
               <a:t>https://arxiv.org/abs/2101.00027</a:t>
+            </a:r>
+          </a:p>
+        </p:txBody>
+      </p:sp>
+      <p:sp>
+        <p:nvSpPr>
+          <p:cNvPr id="6" name="TextBox 5"/>
+          <p:cNvSpPr txBox="1"/>
+          <p:nvPr/>
+        </p:nvSpPr>
+        <p:spPr>
+          <a:xfrm>
+            <a:off x="594360" y="4305300"/>
+            <a:ext cx="7955280" cy="317500"/>
+          </a:xfrm>
+          <a:prstGeom prst="rect">
+            <a:avLst/>
+          </a:prstGeom>
+          <a:noFill/>
+        </p:spPr>
+        <p:txBody>
+          <a:bodyPr wrap="none">
+            <a:spAutoFit/>
+          </a:bodyPr>
+          <a:lstStyle/>
+          <a:p>
+            <a:r>
+              <a:rPr sz="1200">
+                <a:solidFill>
+                  <a:srgbClr val="303638"/>
+                </a:solidFill>
+                <a:latin typeface="Noto Sans CJK JP"/>
+              </a:rPr>
+              <a:t>2020年の構築者による分類。○は該当、—は該当すると判断されていない。</a:t>
             </a:r>
           </a:p>
         </p:txBody>
@@ -38845,7 +38919,7 @@
                 <a:ea typeface="Noto Sans CJK JP"/>
                 <a:cs typeface="Noto Sans"/>
               </a:rPr>
-              <a:t>幅広い分野の文章を使い、特定のWeb文体に偏らない言語モデルを目指した。Leo GaoらEleutherAIの共同研究として2020年末に公開された。</a:t>
+              <a:t>Web以外の専門的な文章まで学習対象を広げ、幅広い分野で文章を予測できる言語モデルを目指した。Leo GaoらEleutherAIの共同研究として2020年末に公開された。</a:t>
             </a:r>
           </a:p>
           <a:p>
@@ -38875,7 +38949,7 @@
                 <a:ea typeface="Noto Sans CJK JP"/>
                 <a:cs typeface="Noto Sans"/>
               </a:rPr>
-              <a:t>質問に答えを付けた問題集ではない。文章に続くトークンを予測するために、文章自体を学習信号として使う。</a:t>
+              <a:t>文章に続くトークンを予測するために、本文そのものを学習信号として使う。</a:t>
             </a:r>
           </a:p>
         </p:txBody>
@@ -39066,14 +39140,14 @@
                 <a:ea typeface="Noto Sans CJK JP"/>
                 <a:cs typeface="Noto Sans"/>
               </a:rPr>
-              <a:t>HELMは構成要素名で本文を分類する</a:t>
+              <a:t>JSONLから本文と構成要素名を読み出す</a:t>
             </a:r>
           </a:p>
         </p:txBody>
       </p:sp>
       <p:sp>
         <p:nvSpPr>
-          <p:cNvPr id="3" name="Text Placeholder 2"/>
+          <p:cNvPr id="3" name="code-frame"/>
           <p:cNvSpPr>
             <a:spLocks noGrp="1"/>
           </p:cNvSpPr>
@@ -39083,26 +39157,33 @@
         </p:nvSpPr>
         <p:spPr>
           <a:xfrm>
-            <a:off x="594360" y="1463040"/>
-            <a:ext cx="7955279" cy="3044952"/>
+            <a:off x="548640" y="1530731"/>
+            <a:ext cx="8046720" cy="1519809"/>
           </a:xfrm>
+          <a:solidFill>
+            <a:srgbClr val="EBEDEB"/>
+          </a:solidFill>
+          <a:ln>
+            <a:noFill/>
+          </a:ln>
         </p:spPr>
         <p:txBody>
-          <a:bodyPr wrap="square" tIns="91440" bIns="91440">
+          <a:bodyPr wrap="square" tIns="59309" bIns="127000" lIns="152400" rIns="152400" anchor="t">
             <a:noAutofit/>
           </a:bodyPr>
           <a:lstStyle/>
           <a:p>
-            <a:pPr marL="457200" indent="-355600">
+            <a:pPr marL="0" indent="0">
               <a:lnSpc>
-                <a:spcPts val="2379"/>
+                <a:spcPct val="110000"/>
               </a:lnSpc>
-              <a:spcAft>
-                <a:spcPts val="700"/>
-              </a:spcAft>
-              <a:buSzPct val="66500"/>
-              <a:buFont typeface="Noto Sans CJK JP"/>
-              <a:buChar char="●"/>
+              <a:spcBef>
+                <a:spcPts val="0"/>
+              </a:spcBef>
+              <a:spcAft>
+                <a:spcPts val="0"/>
+              </a:spcAft>
+              <a:buNone/>
               <a:defRPr sz="2000" b="0">
                 <a:solidFill>
                   <a:srgbClr val="303437"/>
@@ -39111,28 +39192,29 @@
               </a:defRPr>
             </a:pPr>
             <a:r>
-              <a:rPr sz="2000" b="0" lang="ja-JP" altLang="en-US">
-                <a:solidFill>
-                  <a:srgbClr val="303437"/>
-                </a:solidFill>
-                <a:latin typeface="Noto Sans"/>
-                <a:ea typeface="Noto Sans CJK JP"/>
-                <a:cs typeface="Noto Sans"/>
-              </a:rPr>
-              <a:t>ThePileScenarioは各行のmeta.pile_set_nameを読み、本文を構成要素別のCSVへキャッシュする。referencesは空のまま、本文をinputとしてtestに割り当てる。</a:t>
+              <a:rPr sz="1600" b="0" lang="ja-JP" altLang="en-US">
+                <a:solidFill>
+                  <a:srgbClr val="303437"/>
+                </a:solidFill>
+                <a:latin typeface="DejaVu Sans Mono"/>
+                <a:ea typeface="Noto Sans CJK JP"/>
+                <a:cs typeface="Noto Sans"/>
+              </a:rPr>
+              <a:t>import json</a:t>
             </a:r>
           </a:p>
           <a:p>
-            <a:pPr marL="457200" indent="-355600">
+            <a:pPr marL="0" indent="0">
               <a:lnSpc>
-                <a:spcPts val="2379"/>
+                <a:spcPct val="110000"/>
               </a:lnSpc>
-              <a:spcAft>
-                <a:spcPts val="700"/>
-              </a:spcAft>
-              <a:buSzPct val="66500"/>
-              <a:buFont typeface="Noto Sans CJK JP"/>
-              <a:buChar char="●"/>
+              <a:spcBef>
+                <a:spcPts val="0"/>
+              </a:spcBef>
+              <a:spcAft>
+                <a:spcPts val="0"/>
+              </a:spcAft>
+              <a:buNone/>
               <a:defRPr sz="2000" b="0">
                 <a:solidFill>
                   <a:srgbClr val="303437"/>
@@ -39141,28 +39223,29 @@
               </a:defRPr>
             </a:pPr>
             <a:r>
-              <a:rPr sz="2000" b="0" lang="ja-JP" altLang="en-US">
-                <a:solidFill>
-                  <a:srgbClr val="303437"/>
-                </a:solidFill>
-                <a:latin typeface="Noto Sans"/>
-                <a:ea typeface="Noto Sans CJK JP"/>
-                <a:cs typeface="Noto Sans"/>
-              </a:rPr>
-              <a:t>22構成要素を実装上は受け付けるが、Classic v0.4.0公開run仕様は6構成要素・168モデル実行分だった。実装の対応範囲と、公開結果の範囲は異なる。</a:t>
+              <a:rPr sz="1600" b="0" lang="ja-JP" altLang="en-US">
+                <a:solidFill>
+                  <a:srgbClr val="303437"/>
+                </a:solidFill>
+                <a:latin typeface="DejaVu Sans Mono"/>
+                <a:ea typeface="Noto Sans CJK JP"/>
+                <a:cs typeface="Noto Sans"/>
+              </a:rPr>
+              <a:t>with open("sample.jsonl", encoding="utf-8") as f:</a:t>
             </a:r>
           </a:p>
           <a:p>
-            <a:pPr marL="457200" indent="-355600">
+            <a:pPr marL="0" indent="0">
               <a:lnSpc>
-                <a:spcPts val="2379"/>
+                <a:spcPct val="110000"/>
               </a:lnSpc>
-              <a:spcAft>
-                <a:spcPts val="0"/>
-              </a:spcAft>
-              <a:buSzPct val="66500"/>
-              <a:buFont typeface="Noto Sans CJK JP"/>
-              <a:buChar char="●"/>
+              <a:spcBef>
+                <a:spcPts val="0"/>
+              </a:spcBef>
+              <a:spcAft>
+                <a:spcPts val="0"/>
+              </a:spcAft>
+              <a:buNone/>
               <a:defRPr sz="2000" b="0">
                 <a:solidFill>
                   <a:srgbClr val="303437"/>
@@ -39171,15 +39254,77 @@
               </a:defRPr>
             </a:pPr>
             <a:r>
-              <a:rPr sz="2000" b="0" lang="ja-JP" altLang="en-US">
-                <a:solidFill>
-                  <a:srgbClr val="303437"/>
-                </a:solidFill>
-                <a:latin typeface="Noto Sans"/>
-                <a:ea typeface="Noto Sans CJK JP"/>
-                <a:cs typeface="Noto Sans"/>
-              </a:rPr>
-              <a:t>group0の索引は重複を除いて昇順にし、構成要素内の文書を選ぶ。Ubuntu IRC、BookCorpus2、PhilPapersは文書数が少ないため10分割の対象外である。</a:t>
+              <a:rPr sz="1600" b="0" lang="ja-JP" altLang="en-US">
+                <a:solidFill>
+                  <a:srgbClr val="303437"/>
+                </a:solidFill>
+                <a:latin typeface="DejaVu Sans Mono"/>
+                <a:ea typeface="Noto Sans CJK JP"/>
+                <a:cs typeface="Noto Sans"/>
+              </a:rPr>
+              <a:t>    doc = json.loads(next(f))</a:t>
+            </a:r>
+          </a:p>
+          <a:p>
+            <a:pPr marL="0" indent="0">
+              <a:lnSpc>
+                <a:spcPct val="110000"/>
+              </a:lnSpc>
+              <a:spcBef>
+                <a:spcPts val="0"/>
+              </a:spcBef>
+              <a:spcAft>
+                <a:spcPts val="0"/>
+              </a:spcAft>
+              <a:buNone/>
+              <a:defRPr sz="2000" b="0">
+                <a:solidFill>
+                  <a:srgbClr val="303437"/>
+                </a:solidFill>
+                <a:latin typeface="Noto Sans"/>
+              </a:defRPr>
+            </a:pPr>
+            <a:r>
+              <a:rPr sz="1600" b="0" lang="ja-JP" altLang="en-US">
+                <a:solidFill>
+                  <a:srgbClr val="303437"/>
+                </a:solidFill>
+                <a:latin typeface="DejaVu Sans Mono"/>
+                <a:ea typeface="Noto Sans CJK JP"/>
+                <a:cs typeface="Noto Sans"/>
+              </a:rPr>
+              <a:t>print(doc["meta"]["pile_set_name"])</a:t>
+            </a:r>
+          </a:p>
+          <a:p>
+            <a:pPr marL="0" indent="0">
+              <a:lnSpc>
+                <a:spcPct val="110000"/>
+              </a:lnSpc>
+              <a:spcBef>
+                <a:spcPts val="0"/>
+              </a:spcBef>
+              <a:spcAft>
+                <a:spcPts val="0"/>
+              </a:spcAft>
+              <a:buNone/>
+              <a:defRPr sz="2000" b="0">
+                <a:solidFill>
+                  <a:srgbClr val="303437"/>
+                </a:solidFill>
+                <a:latin typeface="Noto Sans"/>
+              </a:defRPr>
+            </a:pPr>
+            <a:r>
+              <a:rPr sz="1600" b="0" lang="ja-JP" altLang="en-US">
+                <a:solidFill>
+                  <a:srgbClr val="303437"/>
+                </a:solidFill>
+                <a:latin typeface="DejaVu Sans Mono"/>
+                <a:ea typeface="Noto Sans CJK JP"/>
+                <a:cs typeface="Noto Sans"/>
+              </a:rPr>
+              <a:t>print(doc["text"])</a:t>
             </a:r>
           </a:p>
         </p:txBody>
@@ -39309,1012 +39454,16 @@
           </a:p>
         </p:txBody>
       </p:sp>
-    </p:spTree>
-  </p:cSld>
-  <p:clrMapOvr>
-    <a:masterClrMapping/>
-  </p:clrMapOvr>
-</p:sld>
-</file>
-
-<file path=ppt/slides/slide51.xml><?xml version="1.0" encoding="utf-8"?>
-<p:sld xmlns:a="http://schemas.openxmlformats.org/drawingml/2006/main" xmlns:p="http://schemas.openxmlformats.org/presentationml/2006/main" xmlns:r="http://schemas.openxmlformats.org/officeDocument/2006/relationships">
-  <p:cSld>
-    <p:spTree>
-      <p:nvGrpSpPr>
-        <p:cNvPr id="1" name=""/>
-        <p:cNvGrpSpPr/>
-        <p:nvPr/>
-      </p:nvGrpSpPr>
-      <p:grpSpPr/>
       <p:sp>
         <p:nvSpPr>
-          <p:cNvPr id="2" name="Title 1"/>
-          <p:cNvSpPr>
-            <a:spLocks noGrp="1"/>
-          </p:cNvSpPr>
-          <p:nvPr>
-            <p:ph type="title"/>
-          </p:nvPr>
-        </p:nvSpPr>
-        <p:spPr>
-          <a:xfrm>
-            <a:off x="468172" y="650138"/>
-            <a:ext cx="8206740" cy="616305"/>
-          </a:xfrm>
-        </p:spPr>
-        <p:txBody>
-          <a:bodyPr wrap="square" lIns="0" rIns="0" tIns="0" bIns="0">
-            <a:noAutofit/>
-          </a:bodyPr>
-          <a:lstStyle/>
-          <a:p>
-            <a:pPr algn="l">
-              <a:lnSpc>
-                <a:spcPct val="110000"/>
-              </a:lnSpc>
-              <a:buNone/>
-              <a:defRPr sz="2800" b="0">
-                <a:solidFill>
-                  <a:srgbClr val="303437"/>
-                </a:solidFill>
-                <a:latin typeface="Noto Sans"/>
-              </a:defRPr>
-            </a:pPr>
-            <a:r>
-              <a:rPr sz="2800" b="1" lang="ja-JP" altLang="en-US">
-                <a:solidFill>
-                  <a:srgbClr val="303437"/>
-                </a:solidFill>
-                <a:latin typeface="Noto Sans"/>
-                <a:ea typeface="Noto Sans CJK JP"/>
-                <a:cs typeface="Noto Sans"/>
-              </a:rPr>
-              <a:t>9実行の採点対象トークン数は異なる</a:t>
-            </a:r>
-          </a:p>
-        </p:txBody>
-      </p:sp>
-      <p:sp>
-        <p:nvSpPr>
-          <p:cNvPr id="3" name="Title 2"/>
-          <p:cNvSpPr>
-            <a:spLocks noGrp="1"/>
-          </p:cNvSpPr>
-          <p:nvPr>
-            <p:ph type="title" idx="2"/>
-          </p:nvPr>
-        </p:nvSpPr>
-        <p:spPr>
-          <a:xfrm>
-            <a:off x="75895" y="0"/>
-            <a:ext cx="8115300" cy="480060"/>
-          </a:xfrm>
-        </p:spPr>
-        <p:txBody>
-          <a:bodyPr wrap="square" lIns="0" rIns="0" tIns="0" bIns="0" anchor="ctr">
-            <a:noAutofit/>
-          </a:bodyPr>
-          <a:lstStyle/>
-          <a:p>
-            <a:pPr algn="l">
-              <a:lnSpc>
-                <a:spcPct val="110000"/>
-              </a:lnSpc>
-              <a:buNone/>
-              <a:defRPr sz="1400" b="0">
-                <a:solidFill>
-                  <a:srgbClr val="303437"/>
-                </a:solidFill>
-                <a:latin typeface="Noto Sans"/>
-              </a:defRPr>
-            </a:pPr>
-            <a:r>
-              <a:rPr sz="1400" b="1" lang="ja-JP" altLang="en-US">
-                <a:solidFill>
-                  <a:srgbClr val="FFFEF8"/>
-                </a:solidFill>
-                <a:latin typeface="Noto Sans"/>
-                <a:ea typeface="Noto Sans CJK JP"/>
-                <a:cs typeface="Noto Sans"/>
-              </a:rPr>
-              <a:t>Appendix: 2. 構成要素と評価条件</a:t>
-            </a:r>
-          </a:p>
-        </p:txBody>
-      </p:sp>
-      <p:graphicFrame>
-        <p:nvGraphicFramePr>
-          <p:cNvPr id="4" name="Table 3"/>
-          <p:cNvGraphicFramePr>
-            <a:graphicFrameLocks noGrp="1"/>
-          </p:cNvGraphicFramePr>
-          <p:nvPr/>
-        </p:nvGraphicFramePr>
-        <p:xfrm>
-          <a:off x="548640" y="1508760"/>
-          <a:ext cx="8046719" cy="1682496"/>
-        </p:xfrm>
-        <a:graphic>
-          <a:graphicData uri="http://schemas.openxmlformats.org/drawingml/2006/table">
-            <a:tbl>
-              <a:tblPr firstRow="0" bandRow="0"/>
-              <a:tblGrid>
-                <a:gridCol w="3749039"/>
-                <a:gridCol w="1417320"/>
-                <a:gridCol w="1417320"/>
-                <a:gridCol w="1463040"/>
-              </a:tblGrid>
-              <a:tr h="420624">
-                <a:tc>
-                  <a:txBody>
-                    <a:bodyPr wrap="square">
-                      <a:noAutofit/>
-                    </a:bodyPr>
-                    <a:lstStyle/>
-                    <a:p>
-                      <a:pPr algn="l">
-                        <a:lnSpc>
-                          <a:spcPts val="2127"/>
-                        </a:lnSpc>
-                        <a:buNone/>
-                        <a:defRPr sz="1850" b="0">
-                          <a:solidFill>
-                            <a:srgbClr val="303437"/>
-                          </a:solidFill>
-                          <a:latin typeface="Noto Sans"/>
-                        </a:defRPr>
-                      </a:pPr>
-                      <a:r>
-                        <a:rPr sz="1850" b="0" lang="ja-JP" altLang="en-US">
-                          <a:solidFill>
-                            <a:srgbClr val="303437"/>
-                          </a:solidFill>
-                          <a:latin typeface="Noto Sans"/>
-                          <a:ea typeface="Noto Sans CJK JP"/>
-                          <a:cs typeface="Noto Sans"/>
-                        </a:rPr>
-                        <a:t>モデル</a:t>
-                      </a:r>
-                    </a:p>
-                  </a:txBody>
-                  <a:tcPr marL="63500" marR="63500" marT="38100" marB="38100" anchor="ctr">
-                    <a:lnL w="7620">
-                      <a:noFill/>
-                    </a:lnL>
-                    <a:lnR w="7620">
-                      <a:noFill/>
-                    </a:lnR>
-                    <a:lnT w="15240">
-                      <a:solidFill>
-                        <a:srgbClr val="626669"/>
-                      </a:solidFill>
-                      <a:prstDash val="solid"/>
-                    </a:lnT>
-                    <a:lnB w="7620">
-                      <a:solidFill>
-                        <a:srgbClr val="626669"/>
-                      </a:solidFill>
-                      <a:prstDash val="solid"/>
-                    </a:lnB>
-                    <a:solidFill>
-                      <a:srgbClr val="FFFEF8"/>
-                    </a:solidFill>
-                  </a:tcPr>
-                </a:tc>
-                <a:tc>
-                  <a:txBody>
-                    <a:bodyPr wrap="square">
-                      <a:noAutofit/>
-                    </a:bodyPr>
-                    <a:lstStyle/>
-                    <a:p>
-                      <a:pPr algn="r">
-                        <a:lnSpc>
-                          <a:spcPts val="2127"/>
-                        </a:lnSpc>
-                        <a:buNone/>
-                        <a:defRPr sz="1850" b="0">
-                          <a:solidFill>
-                            <a:srgbClr val="303437"/>
-                          </a:solidFill>
-                          <a:latin typeface="Noto Sans"/>
-                        </a:defRPr>
-                      </a:pPr>
-                      <a:r>
-                        <a:rPr sz="1850" b="0" lang="ja-JP" altLang="en-US">
-                          <a:solidFill>
-                            <a:srgbClr val="303437"/>
-                          </a:solidFill>
-                          <a:latin typeface="Noto Sans"/>
-                          <a:ea typeface="Noto Sans CJK JP"/>
-                          <a:cs typeface="Noto Sans"/>
-                        </a:rPr>
-                        <a:t>ArXiv</a:t>
-                      </a:r>
-                    </a:p>
-                  </a:txBody>
-                  <a:tcPr marL="63500" marR="63500" marT="38100" marB="38100" anchor="ctr">
-                    <a:lnL w="7620">
-                      <a:noFill/>
-                    </a:lnL>
-                    <a:lnR w="7620">
-                      <a:noFill/>
-                    </a:lnR>
-                    <a:lnT w="15240">
-                      <a:solidFill>
-                        <a:srgbClr val="626669"/>
-                      </a:solidFill>
-                      <a:prstDash val="solid"/>
-                    </a:lnT>
-                    <a:lnB w="7620">
-                      <a:solidFill>
-                        <a:srgbClr val="626669"/>
-                      </a:solidFill>
-                      <a:prstDash val="solid"/>
-                    </a:lnB>
-                    <a:solidFill>
-                      <a:srgbClr val="FFFEF8"/>
-                    </a:solidFill>
-                  </a:tcPr>
-                </a:tc>
-                <a:tc>
-                  <a:txBody>
-                    <a:bodyPr wrap="square">
-                      <a:noAutofit/>
-                    </a:bodyPr>
-                    <a:lstStyle/>
-                    <a:p>
-                      <a:pPr algn="r">
-                        <a:lnSpc>
-                          <a:spcPts val="2127"/>
-                        </a:lnSpc>
-                        <a:buNone/>
-                        <a:defRPr sz="1850" b="0">
-                          <a:solidFill>
-                            <a:srgbClr val="303437"/>
-                          </a:solidFill>
-                          <a:latin typeface="Noto Sans"/>
-                        </a:defRPr>
-                      </a:pPr>
-                      <a:r>
-                        <a:rPr sz="1850" b="0" lang="ja-JP" altLang="en-US">
-                          <a:solidFill>
-                            <a:srgbClr val="303437"/>
-                          </a:solidFill>
-                          <a:latin typeface="Noto Sans"/>
-                          <a:ea typeface="Noto Sans CJK JP"/>
-                          <a:cs typeface="Noto Sans"/>
-                        </a:rPr>
-                        <a:t>Github</a:t>
-                      </a:r>
-                    </a:p>
-                  </a:txBody>
-                  <a:tcPr marL="63500" marR="63500" marT="38100" marB="38100" anchor="ctr">
-                    <a:lnL w="7620">
-                      <a:noFill/>
-                    </a:lnL>
-                    <a:lnR w="7620">
-                      <a:noFill/>
-                    </a:lnR>
-                    <a:lnT w="15240">
-                      <a:solidFill>
-                        <a:srgbClr val="626669"/>
-                      </a:solidFill>
-                      <a:prstDash val="solid"/>
-                    </a:lnT>
-                    <a:lnB w="7620">
-                      <a:solidFill>
-                        <a:srgbClr val="626669"/>
-                      </a:solidFill>
-                      <a:prstDash val="solid"/>
-                    </a:lnB>
-                    <a:solidFill>
-                      <a:srgbClr val="FFFEF8"/>
-                    </a:solidFill>
-                  </a:tcPr>
-                </a:tc>
-                <a:tc>
-                  <a:txBody>
-                    <a:bodyPr wrap="square">
-                      <a:noAutofit/>
-                    </a:bodyPr>
-                    <a:lstStyle/>
-                    <a:p>
-                      <a:pPr algn="r">
-                        <a:lnSpc>
-                          <a:spcPts val="2127"/>
-                        </a:lnSpc>
-                        <a:buNone/>
-                        <a:defRPr sz="1850" b="0">
-                          <a:solidFill>
-                            <a:srgbClr val="303437"/>
-                          </a:solidFill>
-                          <a:latin typeface="Noto Sans"/>
-                        </a:defRPr>
-                      </a:pPr>
-                      <a:r>
-                        <a:rPr sz="1850" b="0" lang="ja-JP" altLang="en-US">
-                          <a:solidFill>
-                            <a:srgbClr val="303437"/>
-                          </a:solidFill>
-                          <a:latin typeface="Noto Sans"/>
-                          <a:ea typeface="Noto Sans CJK JP"/>
-                          <a:cs typeface="Noto Sans"/>
-                        </a:rPr>
-                        <a:t>Wikipedia</a:t>
-                      </a:r>
-                    </a:p>
-                  </a:txBody>
-                  <a:tcPr marL="63500" marR="63500" marT="38100" marB="38100" anchor="ctr">
-                    <a:lnL w="7620">
-                      <a:noFill/>
-                    </a:lnL>
-                    <a:lnR w="7620">
-                      <a:noFill/>
-                    </a:lnR>
-                    <a:lnT w="15240">
-                      <a:solidFill>
-                        <a:srgbClr val="626669"/>
-                      </a:solidFill>
-                      <a:prstDash val="solid"/>
-                    </a:lnT>
-                    <a:lnB w="7620">
-                      <a:solidFill>
-                        <a:srgbClr val="626669"/>
-                      </a:solidFill>
-                      <a:prstDash val="solid"/>
-                    </a:lnB>
-                    <a:solidFill>
-                      <a:srgbClr val="FFFEF8"/>
-                    </a:solidFill>
-                  </a:tcPr>
-                </a:tc>
-              </a:tr>
-              <a:tr h="420624">
-                <a:tc>
-                  <a:txBody>
-                    <a:bodyPr wrap="square">
-                      <a:noAutofit/>
-                    </a:bodyPr>
-                    <a:lstStyle/>
-                    <a:p>
-                      <a:pPr algn="l">
-                        <a:lnSpc>
-                          <a:spcPts val="2127"/>
-                        </a:lnSpc>
-                        <a:buNone/>
-                        <a:defRPr sz="1850" b="0">
-                          <a:solidFill>
-                            <a:srgbClr val="303437"/>
-                          </a:solidFill>
-                          <a:latin typeface="Noto Sans"/>
-                        </a:defRPr>
-                      </a:pPr>
-                      <a:r>
-                        <a:rPr sz="1850" b="0" lang="ja-JP" altLang="en-US">
-                          <a:solidFill>
-                            <a:srgbClr val="303437"/>
-                          </a:solidFill>
-                          <a:latin typeface="Noto Sans"/>
-                          <a:ea typeface="Noto Sans CJK JP"/>
-                          <a:cs typeface="Noto Sans"/>
-                        </a:rPr>
-                        <a:t>text-davinci-003 (2022)</a:t>
-                      </a:r>
-                    </a:p>
-                  </a:txBody>
-                  <a:tcPr marL="63500" marR="63500" marT="38100" marB="38100" anchor="ctr">
-                    <a:lnL w="7620">
-                      <a:noFill/>
-                    </a:lnL>
-                    <a:lnR w="7620">
-                      <a:noFill/>
-                    </a:lnR>
-                    <a:lnT w="7620">
-                      <a:solidFill>
-                        <a:srgbClr val="626669"/>
-                      </a:solidFill>
-                      <a:prstDash val="solid"/>
-                    </a:lnT>
-                    <a:lnB w="7620">
-                      <a:noFill/>
-                    </a:lnB>
-                    <a:solidFill>
-                      <a:srgbClr val="FFFEF8"/>
-                    </a:solidFill>
-                  </a:tcPr>
-                </a:tc>
-                <a:tc>
-                  <a:txBody>
-                    <a:bodyPr wrap="square">
-                      <a:noAutofit/>
-                    </a:bodyPr>
-                    <a:lstStyle/>
-                    <a:p>
-                      <a:pPr algn="r">
-                        <a:lnSpc>
-                          <a:spcPts val="2127"/>
-                        </a:lnSpc>
-                        <a:buNone/>
-                        <a:defRPr sz="1850" b="0">
-                          <a:solidFill>
-                            <a:srgbClr val="303437"/>
-                          </a:solidFill>
-                          <a:latin typeface="Noto Sans"/>
-                        </a:defRPr>
-                      </a:pPr>
-                      <a:r>
-                        <a:rPr sz="1850" b="0" lang="ja-JP" altLang="en-US">
-                          <a:solidFill>
-                            <a:srgbClr val="303437"/>
-                          </a:solidFill>
-                          <a:latin typeface="Noto Sans"/>
-                          <a:ea typeface="Noto Sans CJK JP"/>
-                          <a:cs typeface="Noto Sans"/>
-                        </a:rPr>
-                        <a:t>3508</a:t>
-                      </a:r>
-                    </a:p>
-                  </a:txBody>
-                  <a:tcPr marL="63500" marR="63500" marT="38100" marB="38100" anchor="ctr">
-                    <a:lnL w="7620">
-                      <a:noFill/>
-                    </a:lnL>
-                    <a:lnR w="7620">
-                      <a:noFill/>
-                    </a:lnR>
-                    <a:lnT w="7620">
-                      <a:solidFill>
-                        <a:srgbClr val="626669"/>
-                      </a:solidFill>
-                      <a:prstDash val="solid"/>
-                    </a:lnT>
-                    <a:lnB w="7620">
-                      <a:noFill/>
-                    </a:lnB>
-                    <a:solidFill>
-                      <a:srgbClr val="FFFEF8"/>
-                    </a:solidFill>
-                  </a:tcPr>
-                </a:tc>
-                <a:tc>
-                  <a:txBody>
-                    <a:bodyPr wrap="square">
-                      <a:noAutofit/>
-                    </a:bodyPr>
-                    <a:lstStyle/>
-                    <a:p>
-                      <a:pPr algn="r">
-                        <a:lnSpc>
-                          <a:spcPts val="2127"/>
-                        </a:lnSpc>
-                        <a:buNone/>
-                        <a:defRPr sz="1850" b="0">
-                          <a:solidFill>
-                            <a:srgbClr val="303437"/>
-                          </a:solidFill>
-                          <a:latin typeface="Noto Sans"/>
-                        </a:defRPr>
-                      </a:pPr>
-                      <a:r>
-                        <a:rPr sz="1850" b="0" lang="ja-JP" altLang="en-US">
-                          <a:solidFill>
-                            <a:srgbClr val="303437"/>
-                          </a:solidFill>
-                          <a:latin typeface="Noto Sans"/>
-                          <a:ea typeface="Noto Sans CJK JP"/>
-                          <a:cs typeface="Noto Sans"/>
-                        </a:rPr>
-                        <a:t>1414</a:t>
-                      </a:r>
-                    </a:p>
-                  </a:txBody>
-                  <a:tcPr marL="63500" marR="63500" marT="38100" marB="38100" anchor="ctr">
-                    <a:lnL w="7620">
-                      <a:noFill/>
-                    </a:lnL>
-                    <a:lnR w="7620">
-                      <a:noFill/>
-                    </a:lnR>
-                    <a:lnT w="7620">
-                      <a:solidFill>
-                        <a:srgbClr val="626669"/>
-                      </a:solidFill>
-                      <a:prstDash val="solid"/>
-                    </a:lnT>
-                    <a:lnB w="7620">
-                      <a:noFill/>
-                    </a:lnB>
-                    <a:solidFill>
-                      <a:srgbClr val="FFFEF8"/>
-                    </a:solidFill>
-                  </a:tcPr>
-                </a:tc>
-                <a:tc>
-                  <a:txBody>
-                    <a:bodyPr wrap="square">
-                      <a:noAutofit/>
-                    </a:bodyPr>
-                    <a:lstStyle/>
-                    <a:p>
-                      <a:pPr algn="r">
-                        <a:lnSpc>
-                          <a:spcPts val="2127"/>
-                        </a:lnSpc>
-                        <a:buNone/>
-                        <a:defRPr sz="1850" b="0">
-                          <a:solidFill>
-                            <a:srgbClr val="303437"/>
-                          </a:solidFill>
-                          <a:latin typeface="Noto Sans"/>
-                        </a:defRPr>
-                      </a:pPr>
-                      <a:r>
-                        <a:rPr sz="1850" b="0" lang="ja-JP" altLang="en-US">
-                          <a:solidFill>
-                            <a:srgbClr val="303437"/>
-                          </a:solidFill>
-                          <a:latin typeface="Noto Sans"/>
-                          <a:ea typeface="Noto Sans CJK JP"/>
-                          <a:cs typeface="Noto Sans"/>
-                        </a:rPr>
-                        <a:t>639</a:t>
-                      </a:r>
-                    </a:p>
-                  </a:txBody>
-                  <a:tcPr marL="63500" marR="63500" marT="38100" marB="38100" anchor="ctr">
-                    <a:lnL w="7620">
-                      <a:noFill/>
-                    </a:lnL>
-                    <a:lnR w="7620">
-                      <a:noFill/>
-                    </a:lnR>
-                    <a:lnT w="7620">
-                      <a:solidFill>
-                        <a:srgbClr val="626669"/>
-                      </a:solidFill>
-                      <a:prstDash val="solid"/>
-                    </a:lnT>
-                    <a:lnB w="7620">
-                      <a:noFill/>
-                    </a:lnB>
-                    <a:solidFill>
-                      <a:srgbClr val="FFFEF8"/>
-                    </a:solidFill>
-                  </a:tcPr>
-                </a:tc>
-              </a:tr>
-              <a:tr h="420624">
-                <a:tc>
-                  <a:txBody>
-                    <a:bodyPr wrap="square">
-                      <a:noAutofit/>
-                    </a:bodyPr>
-                    <a:lstStyle/>
-                    <a:p>
-                      <a:pPr algn="l">
-                        <a:lnSpc>
-                          <a:spcPts val="2127"/>
-                        </a:lnSpc>
-                        <a:buNone/>
-                        <a:defRPr sz="1850" b="0">
-                          <a:solidFill>
-                            <a:srgbClr val="303437"/>
-                          </a:solidFill>
-                          <a:latin typeface="Noto Sans"/>
-                        </a:defRPr>
-                      </a:pPr>
-                      <a:r>
-                        <a:rPr sz="1850" b="0" lang="ja-JP" altLang="en-US">
-                          <a:solidFill>
-                            <a:srgbClr val="303437"/>
-                          </a:solidFill>
-                          <a:latin typeface="Noto Sans"/>
-                          <a:ea typeface="Noto Sans CJK JP"/>
-                          <a:cs typeface="Noto Sans"/>
-                        </a:rPr>
-                        <a:t>BLOOM (2022)</a:t>
-                      </a:r>
-                    </a:p>
-                  </a:txBody>
-                  <a:tcPr marL="63500" marR="63500" marT="38100" marB="38100" anchor="ctr">
-                    <a:lnL w="7620">
-                      <a:noFill/>
-                    </a:lnL>
-                    <a:lnR w="7620">
-                      <a:noFill/>
-                    </a:lnR>
-                    <a:lnT w="7620">
-                      <a:noFill/>
-                    </a:lnT>
-                    <a:lnB w="7620">
-                      <a:noFill/>
-                    </a:lnB>
-                    <a:solidFill>
-                      <a:srgbClr val="FFFEF8"/>
-                    </a:solidFill>
-                  </a:tcPr>
-                </a:tc>
-                <a:tc>
-                  <a:txBody>
-                    <a:bodyPr wrap="square">
-                      <a:noAutofit/>
-                    </a:bodyPr>
-                    <a:lstStyle/>
-                    <a:p>
-                      <a:pPr algn="r">
-                        <a:lnSpc>
-                          <a:spcPts val="2127"/>
-                        </a:lnSpc>
-                        <a:buNone/>
-                        <a:defRPr sz="1850" b="0">
-                          <a:solidFill>
-                            <a:srgbClr val="303437"/>
-                          </a:solidFill>
-                          <a:latin typeface="Noto Sans"/>
-                        </a:defRPr>
-                      </a:pPr>
-                      <a:r>
-                        <a:rPr sz="1850" b="0" lang="ja-JP" altLang="en-US">
-                          <a:solidFill>
-                            <a:srgbClr val="303437"/>
-                          </a:solidFill>
-                          <a:latin typeface="Noto Sans"/>
-                          <a:ea typeface="Noto Sans CJK JP"/>
-                          <a:cs typeface="Noto Sans"/>
-                        </a:rPr>
-                        <a:t>1914</a:t>
-                      </a:r>
-                    </a:p>
-                  </a:txBody>
-                  <a:tcPr marL="63500" marR="63500" marT="38100" marB="38100" anchor="ctr">
-                    <a:lnL w="7620">
-                      <a:noFill/>
-                    </a:lnL>
-                    <a:lnR w="7620">
-                      <a:noFill/>
-                    </a:lnR>
-                    <a:lnT w="7620">
-                      <a:noFill/>
-                    </a:lnT>
-                    <a:lnB w="7620">
-                      <a:noFill/>
-                    </a:lnB>
-                    <a:solidFill>
-                      <a:srgbClr val="FFFEF8"/>
-                    </a:solidFill>
-                  </a:tcPr>
-                </a:tc>
-                <a:tc>
-                  <a:txBody>
-                    <a:bodyPr wrap="square">
-                      <a:noAutofit/>
-                    </a:bodyPr>
-                    <a:lstStyle/>
-                    <a:p>
-                      <a:pPr algn="r">
-                        <a:lnSpc>
-                          <a:spcPts val="2127"/>
-                        </a:lnSpc>
-                        <a:buNone/>
-                        <a:defRPr sz="1850" b="0">
-                          <a:solidFill>
-                            <a:srgbClr val="303437"/>
-                          </a:solidFill>
-                          <a:latin typeface="Noto Sans"/>
-                        </a:defRPr>
-                      </a:pPr>
-                      <a:r>
-                        <a:rPr sz="1850" b="0" lang="ja-JP" altLang="en-US">
-                          <a:solidFill>
-                            <a:srgbClr val="303437"/>
-                          </a:solidFill>
-                          <a:latin typeface="Noto Sans"/>
-                          <a:ea typeface="Noto Sans CJK JP"/>
-                          <a:cs typeface="Noto Sans"/>
-                        </a:rPr>
-                        <a:t>1031</a:t>
-                      </a:r>
-                    </a:p>
-                  </a:txBody>
-                  <a:tcPr marL="63500" marR="63500" marT="38100" marB="38100" anchor="ctr">
-                    <a:lnL w="7620">
-                      <a:noFill/>
-                    </a:lnL>
-                    <a:lnR w="7620">
-                      <a:noFill/>
-                    </a:lnR>
-                    <a:lnT w="7620">
-                      <a:noFill/>
-                    </a:lnT>
-                    <a:lnB w="7620">
-                      <a:noFill/>
-                    </a:lnB>
-                    <a:solidFill>
-                      <a:srgbClr val="FFFEF8"/>
-                    </a:solidFill>
-                  </a:tcPr>
-                </a:tc>
-                <a:tc>
-                  <a:txBody>
-                    <a:bodyPr wrap="square">
-                      <a:noAutofit/>
-                    </a:bodyPr>
-                    <a:lstStyle/>
-                    <a:p>
-                      <a:pPr algn="r">
-                        <a:lnSpc>
-                          <a:spcPts val="2127"/>
-                        </a:lnSpc>
-                        <a:buNone/>
-                        <a:defRPr sz="1850" b="0">
-                          <a:solidFill>
-                            <a:srgbClr val="303437"/>
-                          </a:solidFill>
-                          <a:latin typeface="Noto Sans"/>
-                        </a:defRPr>
-                      </a:pPr>
-                      <a:r>
-                        <a:rPr sz="1850" b="0" lang="ja-JP" altLang="en-US">
-                          <a:solidFill>
-                            <a:srgbClr val="303437"/>
-                          </a:solidFill>
-                          <a:latin typeface="Noto Sans"/>
-                          <a:ea typeface="Noto Sans CJK JP"/>
-                          <a:cs typeface="Noto Sans"/>
-                        </a:rPr>
-                        <a:t>576</a:t>
-                      </a:r>
-                    </a:p>
-                  </a:txBody>
-                  <a:tcPr marL="63500" marR="63500" marT="38100" marB="38100" anchor="ctr">
-                    <a:lnL w="7620">
-                      <a:noFill/>
-                    </a:lnL>
-                    <a:lnR w="7620">
-                      <a:noFill/>
-                    </a:lnR>
-                    <a:lnT w="7620">
-                      <a:noFill/>
-                    </a:lnT>
-                    <a:lnB w="7620">
-                      <a:noFill/>
-                    </a:lnB>
-                    <a:solidFill>
-                      <a:srgbClr val="FFFEF8"/>
-                    </a:solidFill>
-                  </a:tcPr>
-                </a:tc>
-              </a:tr>
-              <a:tr h="420624">
-                <a:tc>
-                  <a:txBody>
-                    <a:bodyPr wrap="square">
-                      <a:noAutofit/>
-                    </a:bodyPr>
-                    <a:lstStyle/>
-                    <a:p>
-                      <a:pPr algn="l">
-                        <a:lnSpc>
-                          <a:spcPts val="2127"/>
-                        </a:lnSpc>
-                        <a:buNone/>
-                        <a:defRPr sz="1850" b="0">
-                          <a:solidFill>
-                            <a:srgbClr val="303437"/>
-                          </a:solidFill>
-                          <a:latin typeface="Noto Sans"/>
-                        </a:defRPr>
-                      </a:pPr>
-                      <a:r>
-                        <a:rPr sz="1850" b="0" lang="ja-JP" altLang="en-US">
-                          <a:solidFill>
-                            <a:srgbClr val="303437"/>
-                          </a:solidFill>
-                          <a:latin typeface="Noto Sans"/>
-                          <a:ea typeface="Noto Sans CJK JP"/>
-                          <a:cs typeface="Noto Sans"/>
-                        </a:rPr>
-                        <a:t>OPT-175B (2022)</a:t>
-                      </a:r>
-                    </a:p>
-                  </a:txBody>
-                  <a:tcPr marL="63500" marR="63500" marT="38100" marB="38100" anchor="ctr">
-                    <a:lnL w="7620">
-                      <a:noFill/>
-                    </a:lnL>
-                    <a:lnR w="7620">
-                      <a:noFill/>
-                    </a:lnR>
-                    <a:lnT w="7620">
-                      <a:noFill/>
-                    </a:lnT>
-                    <a:lnB w="15240">
-                      <a:solidFill>
-                        <a:srgbClr val="626669"/>
-                      </a:solidFill>
-                      <a:prstDash val="solid"/>
-                    </a:lnB>
-                    <a:solidFill>
-                      <a:srgbClr val="FFFEF8"/>
-                    </a:solidFill>
-                  </a:tcPr>
-                </a:tc>
-                <a:tc>
-                  <a:txBody>
-                    <a:bodyPr wrap="square">
-                      <a:noAutofit/>
-                    </a:bodyPr>
-                    <a:lstStyle/>
-                    <a:p>
-                      <a:pPr algn="r">
-                        <a:lnSpc>
-                          <a:spcPts val="2127"/>
-                        </a:lnSpc>
-                        <a:buNone/>
-                        <a:defRPr sz="1850" b="0">
-                          <a:solidFill>
-                            <a:srgbClr val="303437"/>
-                          </a:solidFill>
-                          <a:latin typeface="Noto Sans"/>
-                        </a:defRPr>
-                      </a:pPr>
-                      <a:r>
-                        <a:rPr sz="1850" b="0" lang="ja-JP" altLang="en-US">
-                          <a:solidFill>
-                            <a:srgbClr val="303437"/>
-                          </a:solidFill>
-                          <a:latin typeface="Noto Sans"/>
-                          <a:ea typeface="Noto Sans CJK JP"/>
-                          <a:cs typeface="Noto Sans"/>
-                        </a:rPr>
-                        <a:t>1939</a:t>
-                      </a:r>
-                    </a:p>
-                  </a:txBody>
-                  <a:tcPr marL="63500" marR="63500" marT="38100" marB="38100" anchor="ctr">
-                    <a:lnL w="7620">
-                      <a:noFill/>
-                    </a:lnL>
-                    <a:lnR w="7620">
-                      <a:noFill/>
-                    </a:lnR>
-                    <a:lnT w="7620">
-                      <a:noFill/>
-                    </a:lnT>
-                    <a:lnB w="15240">
-                      <a:solidFill>
-                        <a:srgbClr val="626669"/>
-                      </a:solidFill>
-                      <a:prstDash val="solid"/>
-                    </a:lnB>
-                    <a:solidFill>
-                      <a:srgbClr val="FFFEF8"/>
-                    </a:solidFill>
-                  </a:tcPr>
-                </a:tc>
-                <a:tc>
-                  <a:txBody>
-                    <a:bodyPr wrap="square">
-                      <a:noAutofit/>
-                    </a:bodyPr>
-                    <a:lstStyle/>
-                    <a:p>
-                      <a:pPr algn="r">
-                        <a:lnSpc>
-                          <a:spcPts val="2127"/>
-                        </a:lnSpc>
-                        <a:buNone/>
-                        <a:defRPr sz="1850" b="0">
-                          <a:solidFill>
-                            <a:srgbClr val="303437"/>
-                          </a:solidFill>
-                          <a:latin typeface="Noto Sans"/>
-                        </a:defRPr>
-                      </a:pPr>
-                      <a:r>
-                        <a:rPr sz="1850" b="0" lang="ja-JP" altLang="en-US">
-                          <a:solidFill>
-                            <a:srgbClr val="303437"/>
-                          </a:solidFill>
-                          <a:latin typeface="Noto Sans"/>
-                          <a:ea typeface="Noto Sans CJK JP"/>
-                          <a:cs typeface="Noto Sans"/>
-                        </a:rPr>
-                        <a:t>1267</a:t>
-                      </a:r>
-                    </a:p>
-                  </a:txBody>
-                  <a:tcPr marL="63500" marR="63500" marT="38100" marB="38100" anchor="ctr">
-                    <a:lnL w="7620">
-                      <a:noFill/>
-                    </a:lnL>
-                    <a:lnR w="7620">
-                      <a:noFill/>
-                    </a:lnR>
-                    <a:lnT w="7620">
-                      <a:noFill/>
-                    </a:lnT>
-                    <a:lnB w="15240">
-                      <a:solidFill>
-                        <a:srgbClr val="626669"/>
-                      </a:solidFill>
-                      <a:prstDash val="solid"/>
-                    </a:lnB>
-                    <a:solidFill>
-                      <a:srgbClr val="FFFEF8"/>
-                    </a:solidFill>
-                  </a:tcPr>
-                </a:tc>
-                <a:tc>
-                  <a:txBody>
-                    <a:bodyPr wrap="square">
-                      <a:noAutofit/>
-                    </a:bodyPr>
-                    <a:lstStyle/>
-                    <a:p>
-                      <a:pPr algn="r">
-                        <a:lnSpc>
-                          <a:spcPts val="2127"/>
-                        </a:lnSpc>
-                        <a:buNone/>
-                        <a:defRPr sz="1850" b="0">
-                          <a:solidFill>
-                            <a:srgbClr val="303437"/>
-                          </a:solidFill>
-                          <a:latin typeface="Noto Sans"/>
-                        </a:defRPr>
-                      </a:pPr>
-                      <a:r>
-                        <a:rPr sz="1850" b="0" lang="ja-JP" altLang="en-US">
-                          <a:solidFill>
-                            <a:srgbClr val="303437"/>
-                          </a:solidFill>
-                          <a:latin typeface="Noto Sans"/>
-                          <a:ea typeface="Noto Sans CJK JP"/>
-                          <a:cs typeface="Noto Sans"/>
-                        </a:rPr>
-                        <a:t>598</a:t>
-                      </a:r>
-                    </a:p>
-                  </a:txBody>
-                  <a:tcPr marL="63500" marR="63500" marT="38100" marB="38100" anchor="ctr">
-                    <a:lnL w="7620">
-                      <a:noFill/>
-                    </a:lnL>
-                    <a:lnR w="7620">
-                      <a:noFill/>
-                    </a:lnR>
-                    <a:lnT w="7620">
-                      <a:noFill/>
-                    </a:lnT>
-                    <a:lnB w="15240">
-                      <a:solidFill>
-                        <a:srgbClr val="626669"/>
-                      </a:solidFill>
-                      <a:prstDash val="solid"/>
-                    </a:lnB>
-                    <a:solidFill>
-                      <a:srgbClr val="FFFEF8"/>
-                    </a:solidFill>
-                  </a:tcPr>
-                </a:tc>
-              </a:tr>
-            </a:tbl>
-          </a:graphicData>
-        </a:graphic>
-      </p:graphicFrame>
-      <p:sp>
-        <p:nvSpPr>
-          <p:cNvPr id="5" name="TextBox 4"/>
+          <p:cNvPr id="6" name="TextBox 5"/>
           <p:cNvSpPr txBox="1"/>
           <p:nvPr/>
         </p:nvSpPr>
         <p:spPr>
           <a:xfrm>
-            <a:off x="594360" y="3392424"/>
-            <a:ext cx="7955279" cy="658368"/>
+            <a:off x="594360" y="3606800"/>
+            <a:ext cx="7955280" cy="698500"/>
           </a:xfrm>
           <a:prstGeom prst="rect">
             <a:avLst/>
@@ -40322,116 +39471,19 @@
           <a:noFill/>
         </p:spPr>
         <p:txBody>
-          <a:bodyPr wrap="square" lIns="0" rIns="0" tIns="0" bIns="0">
-            <a:noAutofit/>
+          <a:bodyPr wrap="none">
+            <a:spAutoFit/>
           </a:bodyPr>
           <a:lstStyle/>
           <a:p>
-            <a:pPr algn="l">
-              <a:lnSpc>
-                <a:spcPts val="2047"/>
-              </a:lnSpc>
-              <a:spcBef>
-                <a:spcPts val="0"/>
-              </a:spcBef>
-              <a:spcAft>
-                <a:spcPts val="0"/>
-              </a:spcAft>
-              <a:buNone/>
-              <a:defRPr sz="1750" b="0">
-                <a:solidFill>
-                  <a:srgbClr val="303437"/>
-                </a:solidFill>
-                <a:latin typeface="Noto Sans"/>
-              </a:defRPr>
-            </a:pPr>
-            <a:r>
-              <a:rPr sz="1750" b="0" lang="ja-JP" altLang="en-US">
-                <a:solidFill>
-                  <a:srgbClr val="303437"/>
-                </a:solidFill>
-                <a:latin typeface="Noto Sans"/>
-                <a:ea typeface="Noto Sans CJK JP"/>
-                <a:cs typeface="Noto Sans"/>
-              </a:rPr>
-              <a:t>各モデル要求の平均採点トークン数。文書数ではなく、文書を窓に分けた後の要求単位で集計される。</a:t>
-            </a:r>
-          </a:p>
-        </p:txBody>
-      </p:sp>
-      <p:sp>
-        <p:nvSpPr>
-          <p:cNvPr id="6" name="sources"/>
-          <p:cNvSpPr txBox="1"/>
-          <p:nvPr/>
-        </p:nvSpPr>
-        <p:spPr>
-          <a:xfrm>
-            <a:off x="502920" y="4700016"/>
-            <a:ext cx="8183879" cy="530352"/>
-          </a:xfrm>
-          <a:prstGeom prst="rect">
-            <a:avLst/>
-          </a:prstGeom>
-          <a:noFill/>
-        </p:spPr>
-        <p:txBody>
-          <a:bodyPr wrap="square" lIns="0" rIns="0" tIns="0" bIns="0">
-            <a:noAutofit/>
-          </a:bodyPr>
-          <a:lstStyle/>
-          <a:p>
-            <a:pPr algn="l">
-              <a:lnSpc>
-                <a:spcPts val="940"/>
-              </a:lnSpc>
-              <a:spcBef>
-                <a:spcPts val="0"/>
-              </a:spcBef>
-              <a:spcAft>
-                <a:spcPts val="140"/>
-              </a:spcAft>
-              <a:buNone/>
-              <a:defRPr sz="810" b="0">
-                <a:solidFill>
-                  <a:srgbClr val="303437"/>
-                </a:solidFill>
-                <a:latin typeface="Noto Sans"/>
-              </a:defRPr>
-            </a:pPr>
-            <a:r>
-              <a:rPr sz="810" b="0" lang="ja-JP" altLang="en-US">
-                <a:solidFill>
-                  <a:srgbClr val="626669"/>
-                </a:solidFill>
-                <a:latin typeface="Noto Sans"/>
-                <a:ea typeface="Noto Sans CJK JP"/>
-                <a:cs typeface="Noto Sans"/>
-              </a:rPr>
-              <a:t>[1] Liang et al. (2023). Holistic Evaluation of Language Models. TMLR.</a:t>
-            </a:r>
-            <a:r>
-              <a:rPr sz="810" b="0" lang="ja-JP" altLang="en-US">
-                <a:solidFill>
-                  <a:srgbClr val="626669"/>
-                </a:solidFill>
-                <a:latin typeface="Noto Sans"/>
-                <a:ea typeface="Noto Sans CJK JP"/>
-                <a:cs typeface="Noto Sans"/>
-              </a:rPr>
-              <a:t>  </a:t>
-            </a:r>
-            <a:r>
-              <a:rPr sz="810" b="0" lang="ja-JP" altLang="en-US">
-                <a:solidFill>
-                  <a:srgbClr val="626669"/>
-                </a:solidFill>
-                <a:latin typeface="Noto Sans"/>
-                <a:ea typeface="Noto Sans CJK JP"/>
-                <a:cs typeface="Noto Sans"/>
-                <a:hlinkClick r:id="rId2"/>
-              </a:rPr>
-              <a:t>https://arxiv.org/abs/2211.09110</a:t>
+            <a:r>
+              <a:rPr sz="1800">
+                <a:solidFill>
+                  <a:srgbClr val="303638"/>
+                </a:solidFill>
+                <a:latin typeface="Noto Sans CJK JP"/>
+              </a:rPr>
+              <a:t>sample.jsonlは、1行に1文書のJSONを収めたファイル。textが本文、meta.pile_set_nameが出所の構成要素名を表す。</a:t>
             </a:r>
           </a:p>
         </p:txBody>
@@ -40550,7 +39602,7 @@
                 <a:ea typeface="Noto Sans CJK JP"/>
                 <a:cs typeface="Noto Sans"/>
               </a:rPr>
-              <a:t>構築時の整理では、インターネットで読めること、取得元の利用規約と整合すること、元の著者が利用に同意したことを別々に分類した。</a:t>
+              <a:t>2020年の構築時には、インターネットで読めること、取得元の利用規約と整合すること、元の著者が利用に同意したことを調べた。前の一覧は、そのときの構築者による分類である。</a:t>
             </a:r>
           </a:p>
           <a:p>
@@ -40580,7 +39632,7 @@
                 <a:ea typeface="Noto Sans CJK JP"/>
                 <a:cs typeface="Noto Sans"/>
               </a:rPr>
-              <a:t>たとえばGithubは公開かつ規約整合と整理された一方、著者の同意は一律には認められていない。書籍や字幕には、公開されていても規約・同意の欄を満たさないものがある。</a:t>
+              <a:t>Githubは公開かつ規約に整合すると整理された一方、著者の同意は一律には認められていない。書籍や字幕にも、公開されていても規約・同意の欄を満たさないものがある。</a:t>
             </a:r>
           </a:p>
           <a:p>
@@ -40610,7 +39662,7 @@
                 <a:ea typeface="Noto Sans CJK JP"/>
                 <a:cs typeface="Noto Sans"/>
               </a:rPr>
-              <a:t>これは2020年の構築者による整理であり、個別のライセンス一覧ではない。ミラーの表記だけでなく、各本文の出所と条件を確かめる。</a:t>
+              <a:t>この分類は個別文書のライセンス一覧ではないため、利用時には本文の出所に応じた条件の確認が必要になる。</a:t>
             </a:r>
           </a:p>
         </p:txBody>
@@ -40736,361 +39788,6 @@
                 <a:hlinkClick r:id="rId2"/>
               </a:rPr>
               <a:t>https://arxiv.org/abs/2101.00027</a:t>
-            </a:r>
-          </a:p>
-        </p:txBody>
-      </p:sp>
-    </p:spTree>
-  </p:cSld>
-  <p:clrMapOvr>
-    <a:masterClrMapping/>
-  </p:clrMapOvr>
-</p:sld>
-</file>
-
-<file path=ppt/slides/slide53.xml><?xml version="1.0" encoding="utf-8"?>
-<p:sld xmlns:a="http://schemas.openxmlformats.org/drawingml/2006/main" xmlns:p="http://schemas.openxmlformats.org/presentationml/2006/main" xmlns:r="http://schemas.openxmlformats.org/officeDocument/2006/relationships">
-  <p:cSld>
-    <p:spTree>
-      <p:nvGrpSpPr>
-        <p:cNvPr id="1" name=""/>
-        <p:cNvGrpSpPr/>
-        <p:nvPr/>
-      </p:nvGrpSpPr>
-      <p:grpSpPr/>
-      <p:sp>
-        <p:nvSpPr>
-          <p:cNvPr id="2" name="Title 1"/>
-          <p:cNvSpPr>
-            <a:spLocks noGrp="1"/>
-          </p:cNvSpPr>
-          <p:nvPr>
-            <p:ph type="title"/>
-          </p:nvPr>
-        </p:nvSpPr>
-        <p:spPr>
-          <a:xfrm>
-            <a:off x="468172" y="650138"/>
-            <a:ext cx="8206740" cy="616305"/>
-          </a:xfrm>
-        </p:spPr>
-        <p:txBody>
-          <a:bodyPr wrap="square" lIns="0" rIns="0" tIns="0" bIns="0">
-            <a:noAutofit/>
-          </a:bodyPr>
-          <a:lstStyle/>
-          <a:p>
-            <a:pPr algn="l">
-              <a:lnSpc>
-                <a:spcPct val="110000"/>
-              </a:lnSpc>
-              <a:buNone/>
-              <a:defRPr sz="2800" b="0">
-                <a:solidFill>
-                  <a:srgbClr val="303437"/>
-                </a:solidFill>
-                <a:latin typeface="Noto Sans"/>
-              </a:defRPr>
-            </a:pPr>
-            <a:r>
-              <a:rPr sz="2800" b="1" lang="ja-JP" altLang="en-US">
-                <a:solidFill>
-                  <a:srgbClr val="303437"/>
-                </a:solidFill>
-                <a:latin typeface="Noto Sans"/>
-                <a:ea typeface="Noto Sans CJK JP"/>
-                <a:cs typeface="Noto Sans"/>
-              </a:rPr>
-              <a:t>EleutherAIによる共同制作</a:t>
-            </a:r>
-          </a:p>
-        </p:txBody>
-      </p:sp>
-      <p:sp>
-        <p:nvSpPr>
-          <p:cNvPr id="3" name="Text Placeholder 2"/>
-          <p:cNvSpPr>
-            <a:spLocks noGrp="1"/>
-          </p:cNvSpPr>
-          <p:nvPr>
-            <p:ph type="body" idx="1"/>
-          </p:nvPr>
-        </p:nvSpPr>
-        <p:spPr>
-          <a:xfrm>
-            <a:off x="594360" y="1463040"/>
-            <a:ext cx="7955279" cy="3044952"/>
-          </a:xfrm>
-        </p:spPr>
-        <p:txBody>
-          <a:bodyPr wrap="square" tIns="91440" bIns="91440">
-            <a:noAutofit/>
-          </a:bodyPr>
-          <a:lstStyle/>
-          <a:p>
-            <a:pPr marL="457200" indent="-355600">
-              <a:lnSpc>
-                <a:spcPts val="2379"/>
-              </a:lnSpc>
-              <a:spcAft>
-                <a:spcPts val="700"/>
-              </a:spcAft>
-              <a:buSzPct val="66500"/>
-              <a:buFont typeface="Noto Sans CJK JP"/>
-              <a:buChar char="●"/>
-              <a:defRPr sz="2000" b="0">
-                <a:solidFill>
-                  <a:srgbClr val="303437"/>
-                </a:solidFill>
-                <a:latin typeface="Noto Sans"/>
-              </a:defRPr>
-            </a:pPr>
-            <a:r>
-              <a:rPr sz="2000" b="0" lang="ja-JP" altLang="en-US">
-                <a:solidFill>
-                  <a:srgbClr val="303437"/>
-                </a:solidFill>
-                <a:latin typeface="Noto Sans"/>
-                <a:ea typeface="Noto Sans CJK JP"/>
-                <a:cs typeface="Noto Sans"/>
-              </a:rPr>
-              <a:t>Leo Gaoを第一著者、Connor Leahyを最終著者とする12名が、EleutherAIとして制作した。著者にはStella Biderman、Sid Black、Travis Hoppeらが含まれる。</a:t>
-            </a:r>
-          </a:p>
-          <a:p>
-            <a:pPr marL="457200" indent="-355600">
-              <a:lnSpc>
-                <a:spcPts val="2379"/>
-              </a:lnSpc>
-              <a:spcAft>
-                <a:spcPts val="700"/>
-              </a:spcAft>
-              <a:buSzPct val="66500"/>
-              <a:buFont typeface="Noto Sans CJK JP"/>
-              <a:buChar char="●"/>
-              <a:defRPr sz="2000" b="0">
-                <a:solidFill>
-                  <a:srgbClr val="303437"/>
-                </a:solidFill>
-                <a:latin typeface="Noto Sans"/>
-              </a:defRPr>
-            </a:pPr>
-            <a:r>
-              <a:rPr sz="2000" b="0" lang="ja-JP" altLang="en-US">
-                <a:solidFill>
-                  <a:srgbClr val="303437"/>
-                </a:solidFill>
-                <a:latin typeface="Noto Sans"/>
-                <a:ea typeface="Noto Sans CJK JP"/>
-                <a:cs typeface="Noto Sans"/>
-              </a:rPr>
-              <a:t>新たなWeb・学術データの収集と、既存の書籍・会話・論文データの統合を分担し、前処理と再構築コードを公開した。</a:t>
-            </a:r>
-          </a:p>
-          <a:p>
-            <a:pPr marL="457200" indent="-355600">
-              <a:lnSpc>
-                <a:spcPts val="2379"/>
-              </a:lnSpc>
-              <a:spcAft>
-                <a:spcPts val="0"/>
-              </a:spcAft>
-              <a:buSzPct val="66500"/>
-              <a:buFont typeface="Noto Sans CJK JP"/>
-              <a:buChar char="●"/>
-              <a:defRPr sz="2000" b="0">
-                <a:solidFill>
-                  <a:srgbClr val="303437"/>
-                </a:solidFill>
-                <a:latin typeface="Noto Sans"/>
-              </a:defRPr>
-            </a:pPr>
-            <a:r>
-              <a:rPr sz="2000" b="0" lang="ja-JP" altLang="en-US">
-                <a:solidFill>
-                  <a:srgbClr val="303437"/>
-                </a:solidFill>
-                <a:latin typeface="Noto Sans"/>
-                <a:ea typeface="Noto Sans CJK JP"/>
-                <a:cs typeface="Noto Sans"/>
-              </a:rPr>
-              <a:t>The Pileはその後、GPT-NeoXやPythiaなどの学習基盤となった。Pythiaでは同一データ順と多数のチェックポイントを公開し、モデルの学習過程の比較へ役割を広げた。</a:t>
-            </a:r>
-          </a:p>
-        </p:txBody>
-      </p:sp>
-      <p:sp>
-        <p:nvSpPr>
-          <p:cNvPr id="4" name="Title 3"/>
-          <p:cNvSpPr>
-            <a:spLocks noGrp="1"/>
-          </p:cNvSpPr>
-          <p:nvPr>
-            <p:ph type="title" idx="2"/>
-          </p:nvPr>
-        </p:nvSpPr>
-        <p:spPr>
-          <a:xfrm>
-            <a:off x="75895" y="0"/>
-            <a:ext cx="8115300" cy="480060"/>
-          </a:xfrm>
-        </p:spPr>
-        <p:txBody>
-          <a:bodyPr wrap="square" lIns="0" rIns="0" tIns="0" bIns="0" anchor="ctr">
-            <a:noAutofit/>
-          </a:bodyPr>
-          <a:lstStyle/>
-          <a:p>
-            <a:pPr algn="l">
-              <a:lnSpc>
-                <a:spcPct val="110000"/>
-              </a:lnSpc>
-              <a:buNone/>
-              <a:defRPr sz="1400" b="0">
-                <a:solidFill>
-                  <a:srgbClr val="303437"/>
-                </a:solidFill>
-                <a:latin typeface="Noto Sans"/>
-              </a:defRPr>
-            </a:pPr>
-            <a:r>
-              <a:rPr sz="1400" b="1" lang="ja-JP" altLang="en-US">
-                <a:solidFill>
-                  <a:srgbClr val="FFFEF8"/>
-                </a:solidFill>
-                <a:latin typeface="Noto Sans"/>
-                <a:ea typeface="Noto Sans CJK JP"/>
-                <a:cs typeface="Noto Sans"/>
-              </a:rPr>
-              <a:t>Appendix: 3. 制作機関と参考文献</a:t>
-            </a:r>
-          </a:p>
-        </p:txBody>
-      </p:sp>
-      <p:sp>
-        <p:nvSpPr>
-          <p:cNvPr id="5" name="sources"/>
-          <p:cNvSpPr txBox="1"/>
-          <p:nvPr/>
-        </p:nvSpPr>
-        <p:spPr>
-          <a:xfrm>
-            <a:off x="502920" y="4700016"/>
-            <a:ext cx="8183879" cy="530352"/>
-          </a:xfrm>
-          <a:prstGeom prst="rect">
-            <a:avLst/>
-          </a:prstGeom>
-          <a:noFill/>
-        </p:spPr>
-        <p:txBody>
-          <a:bodyPr wrap="square" lIns="0" rIns="0" tIns="0" bIns="0">
-            <a:noAutofit/>
-          </a:bodyPr>
-          <a:lstStyle/>
-          <a:p>
-            <a:pPr algn="l">
-              <a:lnSpc>
-                <a:spcPts val="940"/>
-              </a:lnSpc>
-              <a:spcBef>
-                <a:spcPts val="0"/>
-              </a:spcBef>
-              <a:spcAft>
-                <a:spcPts val="140"/>
-              </a:spcAft>
-              <a:buNone/>
-              <a:defRPr sz="810" b="0">
-                <a:solidFill>
-                  <a:srgbClr val="303437"/>
-                </a:solidFill>
-                <a:latin typeface="Noto Sans"/>
-              </a:defRPr>
-            </a:pPr>
-            <a:r>
-              <a:rPr sz="810" b="0" lang="ja-JP" altLang="en-US">
-                <a:solidFill>
-                  <a:srgbClr val="626669"/>
-                </a:solidFill>
-                <a:latin typeface="Noto Sans"/>
-                <a:ea typeface="Noto Sans CJK JP"/>
-                <a:cs typeface="Noto Sans"/>
-              </a:rPr>
-              <a:t>[1] Gao et al. (2020). The Pile: An 800GB Dataset of Diverse Text for Language Modeling.</a:t>
-            </a:r>
-            <a:r>
-              <a:rPr sz="810" b="0" lang="ja-JP" altLang="en-US">
-                <a:solidFill>
-                  <a:srgbClr val="626669"/>
-                </a:solidFill>
-                <a:latin typeface="Noto Sans"/>
-                <a:ea typeface="Noto Sans CJK JP"/>
-                <a:cs typeface="Noto Sans"/>
-              </a:rPr>
-              <a:t>  </a:t>
-            </a:r>
-            <a:r>
-              <a:rPr sz="810" b="0" lang="ja-JP" altLang="en-US">
-                <a:solidFill>
-                  <a:srgbClr val="626669"/>
-                </a:solidFill>
-                <a:latin typeface="Noto Sans"/>
-                <a:ea typeface="Noto Sans CJK JP"/>
-                <a:cs typeface="Noto Sans"/>
-                <a:hlinkClick r:id="rId2"/>
-              </a:rPr>
-              <a:t>https://arxiv.org/abs/2101.00027</a:t>
-            </a:r>
-          </a:p>
-          <a:p>
-            <a:pPr>
-              <a:lnSpc>
-                <a:spcPts val="940"/>
-              </a:lnSpc>
-              <a:spcAft>
-                <a:spcPts val="140"/>
-              </a:spcAft>
-              <a:buNone/>
-              <a:defRPr sz="810" b="0">
-                <a:solidFill>
-                  <a:srgbClr val="303437"/>
-                </a:solidFill>
-                <a:latin typeface="Noto Sans"/>
-              </a:defRPr>
-            </a:pPr>
-            <a:r>
-              <a:rPr sz="810" b="0" lang="ja-JP" altLang="en-US">
-                <a:solidFill>
-                  <a:srgbClr val="626669"/>
-                </a:solidFill>
-                <a:latin typeface="Noto Sans"/>
-                <a:ea typeface="Noto Sans CJK JP"/>
-                <a:cs typeface="Noto Sans"/>
-              </a:rPr>
-              <a:t>[2] Biderman et al. (2023). Pythia: A Suite for Analyzing Large Language Models Across Training and Scaling. ICML.</a:t>
-            </a:r>
-            <a:r>
-              <a:rPr sz="810" b="0" lang="ja-JP" altLang="en-US">
-                <a:solidFill>
-                  <a:srgbClr val="626669"/>
-                </a:solidFill>
-                <a:latin typeface="Noto Sans"/>
-                <a:ea typeface="Noto Sans CJK JP"/>
-                <a:cs typeface="Noto Sans"/>
-              </a:rPr>
-              <a:t>  </a:t>
-            </a:r>
-            <a:r>
-              <a:rPr sz="810" b="0" lang="ja-JP" altLang="en-US">
-                <a:solidFill>
-                  <a:srgbClr val="626669"/>
-                </a:solidFill>
-                <a:latin typeface="Noto Sans"/>
-                <a:ea typeface="Noto Sans CJK JP"/>
-                <a:cs typeface="Noto Sans"/>
-                <a:hlinkClick r:id="rId3"/>
-              </a:rPr>
-              <a:t>https://arxiv.org/abs/2304.01373</a:t>
             </a:r>
           </a:p>
         </p:txBody>
@@ -41204,7 +39901,7 @@
                 <a:ea typeface="Noto Sans CJK JP"/>
                 <a:cs typeface="Noto Sans"/>
               </a:rPr>
-              <a:t>Appendix: 3. 制作機関と参考文献</a:t>
+              <a:t>Appendix: 3. 参考文献</a:t>
             </a:r>
           </a:p>
         </p:txBody>
@@ -41325,7 +40022,7 @@
         </p:nvSpPr>
         <p:spPr>
           <a:xfrm>
-            <a:off x="594360" y="2578608"/>
+            <a:off x="594360" y="2654808"/>
             <a:ext cx="7955279" cy="228600"/>
           </a:xfrm>
           <a:prstGeom prst="rect">
@@ -41488,7 +40185,7 @@
         </p:nvSpPr>
         <p:spPr>
           <a:xfrm>
-            <a:off x="594360" y="4087368"/>
+            <a:off x="594360" y="4163568"/>
             <a:ext cx="7955279" cy="228600"/>
           </a:xfrm>
           <a:prstGeom prst="rect">
@@ -41644,7 +40341,7 @@
                 <a:ea typeface="Noto Sans CJK JP"/>
                 <a:cs typeface="Noto Sans"/>
               </a:rPr>
-              <a:t>Appendix: 3. 制作機関と参考文献</a:t>
+              <a:t>Appendix: 3. 参考文献</a:t>
             </a:r>
           </a:p>
         </p:txBody>
@@ -41765,7 +40462,7 @@
         </p:nvSpPr>
         <p:spPr>
           <a:xfrm>
-            <a:off x="594360" y="2578608"/>
+            <a:off x="594360" y="2654808"/>
             <a:ext cx="7955279" cy="228600"/>
           </a:xfrm>
           <a:prstGeom prst="rect">
@@ -41928,7 +40625,7 @@
         </p:nvSpPr>
         <p:spPr>
           <a:xfrm>
-            <a:off x="594360" y="4087368"/>
+            <a:off x="594360" y="4163568"/>
             <a:ext cx="7955279" cy="228600"/>
           </a:xfrm>
           <a:prstGeom prst="rect">
@@ -42084,7 +40781,7 @@
                 <a:ea typeface="Noto Sans CJK JP"/>
                 <a:cs typeface="Noto Sans"/>
               </a:rPr>
-              <a:t>Appendix: 3. 制作機関と参考文献</a:t>
+              <a:t>Appendix: 3. 参考文献</a:t>
             </a:r>
           </a:p>
         </p:txBody>
@@ -42205,7 +40902,7 @@
         </p:nvSpPr>
         <p:spPr>
           <a:xfrm>
-            <a:off x="594360" y="2578608"/>
+            <a:off x="594360" y="2654808"/>
             <a:ext cx="7955279" cy="228600"/>
           </a:xfrm>
           <a:prstGeom prst="rect">
@@ -42355,7 +41052,7 @@
                 <a:ea typeface="Noto Sans CJK JP"/>
                 <a:cs typeface="Noto Sans"/>
               </a:rPr>
-              <a:t>The Pileの先頭10,000文書をデバッグ向けに公開したサンプル。本資料の実例はその先頭100行から抽出した。</a:t>
+              <a:t>The Pileの先頭10,000文書を、デバッグ向けに公開した小規模サンプル。本文と構成要素名の形式を試せる。</a:t>
             </a:r>
           </a:p>
         </p:txBody>
@@ -42368,7 +41065,7 @@
         </p:nvSpPr>
         <p:spPr>
           <a:xfrm>
-            <a:off x="594360" y="4087368"/>
+            <a:off x="594360" y="4163568"/>
             <a:ext cx="7955279" cy="228600"/>
           </a:xfrm>
           <a:prstGeom prst="rect">
@@ -42578,7 +41275,7 @@
                 <a:ea typeface="Noto Sans CJK JP"/>
                 <a:cs typeface="Noto Sans"/>
               </a:rPr>
-              <a:t>公開10kサンプル / row 3 / 全文384字からの連続抜粋</a:t>
+              <a:t>公開サンプルの本文から抜粋</a:t>
             </a:r>
           </a:p>
         </p:txBody>
@@ -42748,7 +41445,7 @@
                 <a:ea typeface="Noto Sans CJK JP"/>
                 <a:cs typeface="Noto Sans"/>
               </a:rPr>
-              <a:t>AmazonはAWS re:InventのMidnight Madnessイベントで新サービスを発表した。Amazon Sumerianは、開発者が仮想現実、拡張現実、3Dアプリケーションを簡単に構築できるようにする。</a:t>
+              <a:t>AmazonはAWS re:InventのMidnight Madnessイベントで新サービスを発表した。Amazon Sumerianは、開発者が仮想現実、拡張現実、3Dアプリケーションを構築しやすくすることを目指したサービスだ。</a:t>
             </a:r>
           </a:p>
         </p:txBody>
@@ -43183,7 +41880,7 @@
                 <a:ea typeface="Noto Sans CJK JP"/>
                 <a:cs typeface="Noto Sans"/>
               </a:rPr>
-              <a:t>公開10kサンプル / row 11 / 全文179字からの連続抜粋</a:t>
+              <a:t>公開サンプルの本文から抜粋</a:t>
             </a:r>
           </a:p>
         </p:txBody>
@@ -43788,7 +42485,7 @@
                 <a:ea typeface="Noto Sans CJK JP"/>
                 <a:cs typeface="Noto Sans"/>
               </a:rPr>
-              <a:t>公開10kサンプル / row 20 / 全文543字からの連続抜粋</a:t>
+              <a:t>公開サンプルの本文から抜粋</a:t>
             </a:r>
           </a:p>
         </p:txBody>
@@ -44282,7 +42979,7 @@
                 <a:ea typeface="Noto Sans CJK JP"/>
                 <a:cs typeface="Noto Sans"/>
               </a:rPr>
-              <a:t>入力は文書のテキスト。モデルは直前までのトークンを条件に、次のトークンへ確率を割り当てる。JSONの括弧や句読点も対象となる。</a:t>
+              <a:t>モデルは直前までのトークンを読み、次のトークンへ確率を割り当てる。トークンは単語の一部や記号を含む単位で、JSONの括弧や句読点も予測の対象になる。</a:t>
             </a:r>
           </a:p>
           <a:p>
@@ -44312,7 +43009,7 @@
                 <a:ea typeface="Noto Sans CJK JP"/>
                 <a:cs typeface="Noto Sans"/>
               </a:rPr>
-              <a:t>学習時には各位置の実際のトークンとの負の対数尤度を小さくする。評価時には、固定した保留文書へ与えた確率を集計する。</a:t>
+              <a:t>学習では、実際に続くトークンへ高い確率を与えるようにする。評価では、学習に使わずに残した文書へ、どれだけ高い確率を与えられるかを測る。</a:t>
             </a:r>
           </a:p>
           <a:p>
@@ -44342,7 +43039,7 @@
                 <a:ea typeface="Noto Sans CJK JP"/>
                 <a:cs typeface="Noto Sans"/>
               </a:rPr>
-              <a:t>前の3例は公開10kサンプルの本文抜粋で、HELMが選んだテスト文書ではない。HELMでは長い文書をモデルの文脈長に合わせて窓へ分け、本文の尤度を計算する。</a:t>
+              <a:t>前の3例は、内容の違いを示す公開サンプルの抜粋。HELMではテスト文書を使い、長い本文はモデルの文脈長に合わせて分割して採点する。</a:t>
             </a:r>
           </a:p>
         </p:txBody>

</xml_diff>

<commit_message>
Center The Pile on corpus composition, training and research use
</commit_message>
<xml_diff>
--- a/slides/datasets-in-10-minutes-the-pile.pptx
+++ b/slides/datasets-in-10-minutes-the-pile.pptx
@@ -22,9 +22,6 @@
     <p:sldId id="270" r:id="rId20"/>
     <p:sldId id="271" r:id="rId21"/>
     <p:sldId id="272" r:id="rId22"/>
-    <p:sldId id="273" r:id="rId23"/>
-    <p:sldId id="274" r:id="rId24"/>
-    <p:sldId id="275" r:id="rId25"/>
     <p:sldId id="276" r:id="rId26"/>
     <p:sldId id="277" r:id="rId27"/>
     <p:sldId id="278" r:id="rId28"/>
@@ -10580,7 +10577,7 @@
                 <a:ea typeface="Noto Sans CJK JP"/>
                 <a:cs typeface="Noto Sans"/>
               </a:rPr>
-              <a:t>3. 学習効果とHELMでの評価</a:t>
+              <a:t>3. 多分野の文章で学習する効果</a:t>
             </a:r>
           </a:p>
         </p:txBody>
@@ -10628,7 +10625,7 @@
                 <a:ea typeface="Noto Sans CJK JP"/>
                 <a:cs typeface="Noto Sans"/>
               </a:rPr>
-              <a:t>3. 学習効果とHELMでの評価</a:t>
+              <a:t>3. 多分野の文章で学習する効果</a:t>
             </a:r>
           </a:p>
         </p:txBody>
@@ -10855,7 +10852,7 @@
                 <a:ea typeface="Noto Sans CJK JP"/>
                 <a:cs typeface="Noto Sans"/>
               </a:rPr>
-              <a:t>3. 学習効果とHELMでの評価</a:t>
+              <a:t>3. 多分野の文章で学習する効果</a:t>
             </a:r>
           </a:p>
         </p:txBody>
@@ -10933,57 +10930,6 @@
                 <a:hlinkClick r:id="rId2"/>
               </a:rPr>
               <a:t>https://arxiv.org/abs/2101.00027</a:t>
-            </a:r>
-          </a:p>
-          <a:p>
-            <a:pPr>
-              <a:lnSpc>
-                <a:spcPts val="940"/>
-              </a:lnSpc>
-              <a:spcAft>
-                <a:spcPts val="140"/>
-              </a:spcAft>
-              <a:buNone/>
-              <a:defRPr sz="810" b="0">
-                <a:solidFill>
-                  <a:srgbClr val="303437"/>
-                </a:solidFill>
-                <a:latin typeface="Noto Sans"/>
-              </a:defRPr>
-            </a:pPr>
-            <a:r>
-              <a:rPr sz="810" b="0" lang="ja-JP" altLang="en-US">
-                <a:solidFill>
-                  <a:srgbClr val="626669"/>
-                </a:solidFill>
-                <a:latin typeface="Noto Sans"/>
-                <a:ea typeface="Noto Sans CJK JP"/>
-                <a:cs typeface="Noto Sans"/>
-              </a:rPr>
-              <a:t>[2] Liang et al. (2023). Holistic Evaluation of Language Models. TMLR.</a:t>
-            </a:r>
-            <a:r>
-              <a:rPr sz="810" b="0" lang="ja-JP" altLang="en-US">
-                <a:solidFill>
-                  <a:srgbClr val="626669"/>
-                </a:solidFill>
-                <a:latin typeface="Noto Sans"/>
-                <a:ea typeface="Noto Sans CJK JP"/>
-                <a:cs typeface="Noto Sans"/>
-              </a:rPr>
-              <a:t>  </a:t>
-            </a:r>
-            <a:r>
-              <a:rPr sz="810" b="0" lang="ja-JP" altLang="en-US">
-                <a:solidFill>
-                  <a:srgbClr val="626669"/>
-                </a:solidFill>
-                <a:latin typeface="Noto Sans"/>
-                <a:ea typeface="Noto Sans CJK JP"/>
-                <a:cs typeface="Noto Sans"/>
-                <a:hlinkClick r:id="rId3"/>
-              </a:rPr>
-              <a:t>https://arxiv.org/abs/2211.09110</a:t>
             </a:r>
           </a:p>
         </p:txBody>
@@ -11097,7 +11043,7 @@
                 <a:ea typeface="Noto Sans CJK JP"/>
                 <a:cs typeface="Noto Sans"/>
               </a:rPr>
-              <a:t>3. 学習効果とHELMでの評価</a:t>
+              <a:t>3. 多分野の文章で学習する効果</a:t>
             </a:r>
           </a:p>
         </p:txBody>
@@ -12111,1407 +12057,6 @@
                 <a:hlinkClick r:id="rId2"/>
               </a:rPr>
               <a:t>https://arxiv.org/abs/2101.00027</a:t>
-            </a:r>
-          </a:p>
-        </p:txBody>
-      </p:sp>
-    </p:spTree>
-  </p:cSld>
-  <p:clrMapOvr>
-    <a:masterClrMapping/>
-  </p:clrMapOvr>
-</p:sld>
-</file>
-
-<file path=ppt/slides/slide18.xml><?xml version="1.0" encoding="utf-8"?>
-<p:sld xmlns:a="http://schemas.openxmlformats.org/drawingml/2006/main" xmlns:p="http://schemas.openxmlformats.org/presentationml/2006/main" xmlns:r="http://schemas.openxmlformats.org/officeDocument/2006/relationships">
-  <p:cSld>
-    <p:spTree>
-      <p:nvGrpSpPr>
-        <p:cNvPr id="1" name=""/>
-        <p:cNvGrpSpPr/>
-        <p:nvPr/>
-      </p:nvGrpSpPr>
-      <p:grpSpPr/>
-      <p:sp>
-        <p:nvSpPr>
-          <p:cNvPr id="2" name="Title 1"/>
-          <p:cNvSpPr>
-            <a:spLocks noGrp="1"/>
-          </p:cNvSpPr>
-          <p:nvPr>
-            <p:ph type="title"/>
-          </p:nvPr>
-        </p:nvSpPr>
-        <p:spPr>
-          <a:xfrm>
-            <a:off x="468172" y="650138"/>
-            <a:ext cx="8206740" cy="616305"/>
-          </a:xfrm>
-        </p:spPr>
-        <p:txBody>
-          <a:bodyPr wrap="square" lIns="0" rIns="0" tIns="0" bIns="0">
-            <a:noAutofit/>
-          </a:bodyPr>
-          <a:lstStyle/>
-          <a:p>
-            <a:pPr algn="l">
-              <a:lnSpc>
-                <a:spcPct val="110000"/>
-              </a:lnSpc>
-              <a:buNone/>
-              <a:defRPr sz="2800" b="0">
-                <a:solidFill>
-                  <a:srgbClr val="303437"/>
-                </a:solidFill>
-                <a:latin typeface="Noto Sans"/>
-              </a:defRPr>
-            </a:pPr>
-            <a:r>
-              <a:rPr sz="2800" b="1" lang="ja-JP" altLang="en-US">
-                <a:solidFill>
-                  <a:srgbClr val="303437"/>
-                </a:solidFill>
-                <a:latin typeface="Noto Sans"/>
-                <a:ea typeface="Noto Sans CJK JP"/>
-                <a:cs typeface="Noto Sans"/>
-              </a:rPr>
-              <a:t>HELMでは6分野の文章の予測しやすさを測る</a:t>
-            </a:r>
-          </a:p>
-        </p:txBody>
-      </p:sp>
-      <p:sp>
-        <p:nvSpPr>
-          <p:cNvPr id="3" name="Text Placeholder 2"/>
-          <p:cNvSpPr>
-            <a:spLocks noGrp="1"/>
-          </p:cNvSpPr>
-          <p:nvPr>
-            <p:ph type="body" idx="1"/>
-          </p:nvPr>
-        </p:nvSpPr>
-        <p:spPr>
-          <a:xfrm>
-            <a:off x="594360" y="1463040"/>
-            <a:ext cx="7955279" cy="3044952"/>
-          </a:xfrm>
-        </p:spPr>
-        <p:txBody>
-          <a:bodyPr wrap="square" tIns="91440" bIns="91440">
-            <a:noAutofit/>
-          </a:bodyPr>
-          <a:lstStyle/>
-          <a:p>
-            <a:pPr marL="457200" indent="-355600">
-              <a:lnSpc>
-                <a:spcPts val="2379"/>
-              </a:lnSpc>
-              <a:spcAft>
-                <a:spcPts val="700"/>
-              </a:spcAft>
-              <a:buSzPct val="66500"/>
-              <a:buFont typeface="Noto Sans CJK JP"/>
-              <a:buChar char="●"/>
-              <a:defRPr sz="2000" b="0">
-                <a:solidFill>
-                  <a:srgbClr val="303437"/>
-                </a:solidFill>
-                <a:latin typeface="Noto Sans"/>
-              </a:defRPr>
-            </a:pPr>
-            <a:r>
-              <a:rPr sz="2000" b="0" lang="ja-JP" altLang="en-US">
-                <a:solidFill>
-                  <a:srgbClr val="303437"/>
-                </a:solidFill>
-                <a:latin typeface="Noto Sans"/>
-                <a:ea typeface="Noto Sans CJK JP"/>
-                <a:cs typeface="Noto Sans"/>
-              </a:rPr>
-              <a:t>HELM Classic v0.4.0では、ArXiv、BookCorpus2、Enron Emails、Github、PubMed Central、Wikipedia (en)の6構成要素を評価する。</a:t>
-            </a:r>
-          </a:p>
-          <a:p>
-            <a:pPr marL="457200" indent="-355600">
-              <a:lnSpc>
-                <a:spcPts val="2379"/>
-              </a:lnSpc>
-              <a:spcAft>
-                <a:spcPts val="700"/>
-              </a:spcAft>
-              <a:buSzPct val="66500"/>
-              <a:buFont typeface="Noto Sans CJK JP"/>
-              <a:buChar char="●"/>
-              <a:defRPr sz="2000" b="0">
-                <a:solidFill>
-                  <a:srgbClr val="303437"/>
-                </a:solidFill>
-                <a:latin typeface="Noto Sans"/>
-              </a:defRPr>
-            </a:pPr>
-            <a:r>
-              <a:rPr sz="2000" b="0" lang="ja-JP" altLang="en-US">
-                <a:solidFill>
-                  <a:srgbClr val="303437"/>
-                </a:solidFill>
-                <a:latin typeface="Noto Sans"/>
-                <a:ea typeface="Noto Sans CJK JP"/>
-                <a:cs typeface="Noto Sans"/>
-              </a:rPr>
-              <a:t>テスト文書から分野ごとに評価対象を選び、本文に与える確率を採点する。</a:t>
-            </a:r>
-          </a:p>
-        </p:txBody>
-      </p:sp>
-      <p:sp>
-        <p:nvSpPr>
-          <p:cNvPr id="4" name="Title 3"/>
-          <p:cNvSpPr>
-            <a:spLocks noGrp="1"/>
-          </p:cNvSpPr>
-          <p:nvPr>
-            <p:ph type="title" idx="2"/>
-          </p:nvPr>
-        </p:nvSpPr>
-        <p:spPr>
-          <a:xfrm>
-            <a:off x="75895" y="0"/>
-            <a:ext cx="8115300" cy="480060"/>
-          </a:xfrm>
-        </p:spPr>
-        <p:txBody>
-          <a:bodyPr wrap="square" lIns="0" rIns="0" tIns="0" bIns="0" anchor="ctr">
-            <a:noAutofit/>
-          </a:bodyPr>
-          <a:lstStyle/>
-          <a:p>
-            <a:pPr algn="l">
-              <a:lnSpc>
-                <a:spcPct val="110000"/>
-              </a:lnSpc>
-              <a:buNone/>
-              <a:defRPr sz="1400" b="0">
-                <a:solidFill>
-                  <a:srgbClr val="303437"/>
-                </a:solidFill>
-                <a:latin typeface="Noto Sans"/>
-              </a:defRPr>
-            </a:pPr>
-            <a:r>
-              <a:rPr sz="1400" b="1" lang="ja-JP" altLang="en-US">
-                <a:solidFill>
-                  <a:srgbClr val="FFFEF8"/>
-                </a:solidFill>
-                <a:latin typeface="Noto Sans"/>
-                <a:ea typeface="Noto Sans CJK JP"/>
-                <a:cs typeface="Noto Sans"/>
-              </a:rPr>
-              <a:t>3. 学習効果とHELMでの評価</a:t>
-            </a:r>
-          </a:p>
-        </p:txBody>
-      </p:sp>
-      <p:sp>
-        <p:nvSpPr>
-          <p:cNvPr id="5" name="sources"/>
-          <p:cNvSpPr txBox="1"/>
-          <p:nvPr/>
-        </p:nvSpPr>
-        <p:spPr>
-          <a:xfrm>
-            <a:off x="502920" y="4700016"/>
-            <a:ext cx="8183879" cy="530352"/>
-          </a:xfrm>
-          <a:prstGeom prst="rect">
-            <a:avLst/>
-          </a:prstGeom>
-          <a:noFill/>
-        </p:spPr>
-        <p:txBody>
-          <a:bodyPr wrap="square" lIns="0" rIns="0" tIns="0" bIns="0">
-            <a:noAutofit/>
-          </a:bodyPr>
-          <a:lstStyle/>
-          <a:p>
-            <a:pPr algn="l">
-              <a:lnSpc>
-                <a:spcPts val="940"/>
-              </a:lnSpc>
-              <a:spcBef>
-                <a:spcPts val="0"/>
-              </a:spcBef>
-              <a:spcAft>
-                <a:spcPts val="140"/>
-              </a:spcAft>
-              <a:buNone/>
-              <a:defRPr sz="810" b="0">
-                <a:solidFill>
-                  <a:srgbClr val="303437"/>
-                </a:solidFill>
-                <a:latin typeface="Noto Sans"/>
-              </a:defRPr>
-            </a:pPr>
-            <a:r>
-              <a:rPr sz="810" b="0" lang="ja-JP" altLang="en-US">
-                <a:solidFill>
-                  <a:srgbClr val="626669"/>
-                </a:solidFill>
-                <a:latin typeface="Noto Sans"/>
-                <a:ea typeface="Noto Sans CJK JP"/>
-                <a:cs typeface="Noto Sans"/>
-              </a:rPr>
-              <a:t>[1] Stanford CRFM. HELM v0.4.0: ThePileScenario.</a:t>
-            </a:r>
-            <a:r>
-              <a:rPr sz="810" b="0" lang="ja-JP" altLang="en-US">
-                <a:solidFill>
-                  <a:srgbClr val="626669"/>
-                </a:solidFill>
-                <a:latin typeface="Noto Sans"/>
-                <a:ea typeface="Noto Sans CJK JP"/>
-                <a:cs typeface="Noto Sans"/>
-              </a:rPr>
-              <a:t>  </a:t>
-            </a:r>
-            <a:r>
-              <a:rPr sz="810" b="0" lang="ja-JP" altLang="en-US">
-                <a:solidFill>
-                  <a:srgbClr val="626669"/>
-                </a:solidFill>
-                <a:latin typeface="Noto Sans"/>
-                <a:ea typeface="Noto Sans CJK JP"/>
-                <a:cs typeface="Noto Sans"/>
-                <a:hlinkClick r:id="rId2"/>
-              </a:rPr>
-              <a:t>https://github.com/stanford-crfm/helm/blob/v0.4.0/src/helm/benchmark/scenarios/the_pile_scenario.py</a:t>
-            </a:r>
-          </a:p>
-        </p:txBody>
-      </p:sp>
-    </p:spTree>
-  </p:cSld>
-  <p:clrMapOvr>
-    <a:masterClrMapping/>
-  </p:clrMapOvr>
-</p:sld>
-</file>
-
-<file path=ppt/slides/slide19.xml><?xml version="1.0" encoding="utf-8"?>
-<p:sld xmlns:a="http://schemas.openxmlformats.org/drawingml/2006/main" xmlns:p="http://schemas.openxmlformats.org/presentationml/2006/main" xmlns:r="http://schemas.openxmlformats.org/officeDocument/2006/relationships">
-  <p:cSld>
-    <p:spTree>
-      <p:nvGrpSpPr>
-        <p:cNvPr id="1" name=""/>
-        <p:cNvGrpSpPr/>
-        <p:nvPr/>
-      </p:nvGrpSpPr>
-      <p:grpSpPr/>
-      <p:sp>
-        <p:nvSpPr>
-          <p:cNvPr id="2" name="Title 1"/>
-          <p:cNvSpPr>
-            <a:spLocks noGrp="1"/>
-          </p:cNvSpPr>
-          <p:nvPr>
-            <p:ph type="title"/>
-          </p:nvPr>
-        </p:nvSpPr>
-        <p:spPr>
-          <a:xfrm>
-            <a:off x="468172" y="650138"/>
-            <a:ext cx="8206740" cy="616305"/>
-          </a:xfrm>
-        </p:spPr>
-        <p:txBody>
-          <a:bodyPr wrap="square" lIns="0" rIns="0" tIns="0" bIns="0">
-            <a:noAutofit/>
-          </a:bodyPr>
-          <a:lstStyle/>
-          <a:p>
-            <a:pPr algn="l">
-              <a:lnSpc>
-                <a:spcPct val="110000"/>
-              </a:lnSpc>
-              <a:buNone/>
-              <a:defRPr sz="2800" b="0">
-                <a:solidFill>
-                  <a:srgbClr val="303437"/>
-                </a:solidFill>
-                <a:latin typeface="Noto Sans"/>
-              </a:defRPr>
-            </a:pPr>
-            <a:r>
-              <a:rPr sz="2800" b="1" lang="ja-JP" altLang="en-US">
-                <a:solidFill>
-                  <a:srgbClr val="303437"/>
-                </a:solidFill>
-                <a:latin typeface="Noto Sans"/>
-                <a:ea typeface="Noto Sans CJK JP"/>
-                <a:cs typeface="Noto Sans"/>
-              </a:rPr>
-              <a:t>HELMのBPBは分野ごとに傾向が異なる</a:t>
-            </a:r>
-          </a:p>
-        </p:txBody>
-      </p:sp>
-      <p:sp>
-        <p:nvSpPr>
-          <p:cNvPr id="3" name="Title 2"/>
-          <p:cNvSpPr>
-            <a:spLocks noGrp="1"/>
-          </p:cNvSpPr>
-          <p:nvPr>
-            <p:ph type="title" idx="2"/>
-          </p:nvPr>
-        </p:nvSpPr>
-        <p:spPr>
-          <a:xfrm>
-            <a:off x="75895" y="0"/>
-            <a:ext cx="8115300" cy="480060"/>
-          </a:xfrm>
-        </p:spPr>
-        <p:txBody>
-          <a:bodyPr wrap="square" lIns="0" rIns="0" tIns="0" bIns="0" anchor="ctr">
-            <a:noAutofit/>
-          </a:bodyPr>
-          <a:lstStyle/>
-          <a:p>
-            <a:pPr algn="l">
-              <a:lnSpc>
-                <a:spcPct val="110000"/>
-              </a:lnSpc>
-              <a:buNone/>
-              <a:defRPr sz="1400" b="0">
-                <a:solidFill>
-                  <a:srgbClr val="303437"/>
-                </a:solidFill>
-                <a:latin typeface="Noto Sans"/>
-              </a:defRPr>
-            </a:pPr>
-            <a:r>
-              <a:rPr sz="1400" b="1" lang="ja-JP" altLang="en-US">
-                <a:solidFill>
-                  <a:srgbClr val="FFFEF8"/>
-                </a:solidFill>
-                <a:latin typeface="Noto Sans"/>
-                <a:ea typeface="Noto Sans CJK JP"/>
-                <a:cs typeface="Noto Sans"/>
-              </a:rPr>
-              <a:t>3. 学習効果とHELMでの評価</a:t>
-            </a:r>
-          </a:p>
-        </p:txBody>
-      </p:sp>
-      <p:graphicFrame>
-        <p:nvGraphicFramePr>
-          <p:cNvPr id="4" name="Table 3"/>
-          <p:cNvGraphicFramePr>
-            <a:graphicFrameLocks noGrp="1"/>
-          </p:cNvGraphicFramePr>
-          <p:nvPr/>
-        </p:nvGraphicFramePr>
-        <p:xfrm>
-          <a:off x="548640" y="1508760"/>
-          <a:ext cx="8046719" cy="1682496"/>
-        </p:xfrm>
-        <a:graphic>
-          <a:graphicData uri="http://schemas.openxmlformats.org/drawingml/2006/table">
-            <a:tbl>
-              <a:tblPr firstRow="0" bandRow="0"/>
-              <a:tblGrid>
-                <a:gridCol w="3749039"/>
-                <a:gridCol w="1417320"/>
-                <a:gridCol w="1417320"/>
-                <a:gridCol w="1463040"/>
-              </a:tblGrid>
-              <a:tr h="420624">
-                <a:tc>
-                  <a:txBody>
-                    <a:bodyPr wrap="square">
-                      <a:noAutofit/>
-                    </a:bodyPr>
-                    <a:lstStyle/>
-                    <a:p>
-                      <a:pPr algn="l">
-                        <a:lnSpc>
-                          <a:spcPts val="2127"/>
-                        </a:lnSpc>
-                        <a:buNone/>
-                        <a:defRPr sz="1850" b="0">
-                          <a:solidFill>
-                            <a:srgbClr val="303437"/>
-                          </a:solidFill>
-                          <a:latin typeface="Noto Sans"/>
-                        </a:defRPr>
-                      </a:pPr>
-                      <a:r>
-                        <a:rPr sz="1850" b="0" lang="ja-JP" altLang="en-US">
-                          <a:solidFill>
-                            <a:srgbClr val="303437"/>
-                          </a:solidFill>
-                          <a:latin typeface="Noto Sans"/>
-                          <a:ea typeface="Noto Sans CJK JP"/>
-                          <a:cs typeface="Noto Sans"/>
-                        </a:rPr>
-                        <a:t>モデル</a:t>
-                      </a:r>
-                    </a:p>
-                  </a:txBody>
-                  <a:tcPr marL="63500" marR="63500" marT="38100" marB="38100" anchor="ctr">
-                    <a:lnL w="7620">
-                      <a:noFill/>
-                    </a:lnL>
-                    <a:lnR w="7620">
-                      <a:noFill/>
-                    </a:lnR>
-                    <a:lnT w="15240">
-                      <a:solidFill>
-                        <a:srgbClr val="626669"/>
-                      </a:solidFill>
-                      <a:prstDash val="solid"/>
-                    </a:lnT>
-                    <a:lnB w="7620">
-                      <a:solidFill>
-                        <a:srgbClr val="626669"/>
-                      </a:solidFill>
-                      <a:prstDash val="solid"/>
-                    </a:lnB>
-                    <a:solidFill>
-                      <a:srgbClr val="FFFEF8"/>
-                    </a:solidFill>
-                  </a:tcPr>
-                </a:tc>
-                <a:tc>
-                  <a:txBody>
-                    <a:bodyPr wrap="square">
-                      <a:noAutofit/>
-                    </a:bodyPr>
-                    <a:lstStyle/>
-                    <a:p>
-                      <a:pPr algn="r">
-                        <a:lnSpc>
-                          <a:spcPts val="2127"/>
-                        </a:lnSpc>
-                        <a:buNone/>
-                        <a:defRPr sz="1850" b="0">
-                          <a:solidFill>
-                            <a:srgbClr val="303437"/>
-                          </a:solidFill>
-                          <a:latin typeface="Noto Sans"/>
-                        </a:defRPr>
-                      </a:pPr>
-                      <a:r>
-                        <a:rPr sz="1850" b="0" lang="ja-JP" altLang="en-US">
-                          <a:solidFill>
-                            <a:srgbClr val="303437"/>
-                          </a:solidFill>
-                          <a:latin typeface="Noto Sans"/>
-                          <a:ea typeface="Noto Sans CJK JP"/>
-                          <a:cs typeface="Noto Sans"/>
-                        </a:rPr>
-                        <a:t>ArXiv</a:t>
-                      </a:r>
-                    </a:p>
-                  </a:txBody>
-                  <a:tcPr marL="63500" marR="63500" marT="38100" marB="38100" anchor="ctr">
-                    <a:lnL w="7620">
-                      <a:noFill/>
-                    </a:lnL>
-                    <a:lnR w="7620">
-                      <a:noFill/>
-                    </a:lnR>
-                    <a:lnT w="15240">
-                      <a:solidFill>
-                        <a:srgbClr val="626669"/>
-                      </a:solidFill>
-                      <a:prstDash val="solid"/>
-                    </a:lnT>
-                    <a:lnB w="7620">
-                      <a:solidFill>
-                        <a:srgbClr val="626669"/>
-                      </a:solidFill>
-                      <a:prstDash val="solid"/>
-                    </a:lnB>
-                    <a:solidFill>
-                      <a:srgbClr val="FFFEF8"/>
-                    </a:solidFill>
-                  </a:tcPr>
-                </a:tc>
-                <a:tc>
-                  <a:txBody>
-                    <a:bodyPr wrap="square">
-                      <a:noAutofit/>
-                    </a:bodyPr>
-                    <a:lstStyle/>
-                    <a:p>
-                      <a:pPr algn="r">
-                        <a:lnSpc>
-                          <a:spcPts val="2127"/>
-                        </a:lnSpc>
-                        <a:buNone/>
-                        <a:defRPr sz="1850" b="0">
-                          <a:solidFill>
-                            <a:srgbClr val="303437"/>
-                          </a:solidFill>
-                          <a:latin typeface="Noto Sans"/>
-                        </a:defRPr>
-                      </a:pPr>
-                      <a:r>
-                        <a:rPr sz="1850" b="0" lang="ja-JP" altLang="en-US">
-                          <a:solidFill>
-                            <a:srgbClr val="303437"/>
-                          </a:solidFill>
-                          <a:latin typeface="Noto Sans"/>
-                          <a:ea typeface="Noto Sans CJK JP"/>
-                          <a:cs typeface="Noto Sans"/>
-                        </a:rPr>
-                        <a:t>Github</a:t>
-                      </a:r>
-                    </a:p>
-                  </a:txBody>
-                  <a:tcPr marL="63500" marR="63500" marT="38100" marB="38100" anchor="ctr">
-                    <a:lnL w="7620">
-                      <a:noFill/>
-                    </a:lnL>
-                    <a:lnR w="7620">
-                      <a:noFill/>
-                    </a:lnR>
-                    <a:lnT w="15240">
-                      <a:solidFill>
-                        <a:srgbClr val="626669"/>
-                      </a:solidFill>
-                      <a:prstDash val="solid"/>
-                    </a:lnT>
-                    <a:lnB w="7620">
-                      <a:solidFill>
-                        <a:srgbClr val="626669"/>
-                      </a:solidFill>
-                      <a:prstDash val="solid"/>
-                    </a:lnB>
-                    <a:solidFill>
-                      <a:srgbClr val="FFFEF8"/>
-                    </a:solidFill>
-                  </a:tcPr>
-                </a:tc>
-                <a:tc>
-                  <a:txBody>
-                    <a:bodyPr wrap="square">
-                      <a:noAutofit/>
-                    </a:bodyPr>
-                    <a:lstStyle/>
-                    <a:p>
-                      <a:pPr algn="r">
-                        <a:lnSpc>
-                          <a:spcPts val="2127"/>
-                        </a:lnSpc>
-                        <a:buNone/>
-                        <a:defRPr sz="1850" b="0">
-                          <a:solidFill>
-                            <a:srgbClr val="303437"/>
-                          </a:solidFill>
-                          <a:latin typeface="Noto Sans"/>
-                        </a:defRPr>
-                      </a:pPr>
-                      <a:r>
-                        <a:rPr sz="1850" b="0" lang="ja-JP" altLang="en-US">
-                          <a:solidFill>
-                            <a:srgbClr val="303437"/>
-                          </a:solidFill>
-                          <a:latin typeface="Noto Sans"/>
-                          <a:ea typeface="Noto Sans CJK JP"/>
-                          <a:cs typeface="Noto Sans"/>
-                        </a:rPr>
-                        <a:t>Wikipedia</a:t>
-                      </a:r>
-                    </a:p>
-                  </a:txBody>
-                  <a:tcPr marL="63500" marR="63500" marT="38100" marB="38100" anchor="ctr">
-                    <a:lnL w="7620">
-                      <a:noFill/>
-                    </a:lnL>
-                    <a:lnR w="7620">
-                      <a:noFill/>
-                    </a:lnR>
-                    <a:lnT w="15240">
-                      <a:solidFill>
-                        <a:srgbClr val="626669"/>
-                      </a:solidFill>
-                      <a:prstDash val="solid"/>
-                    </a:lnT>
-                    <a:lnB w="7620">
-                      <a:solidFill>
-                        <a:srgbClr val="626669"/>
-                      </a:solidFill>
-                      <a:prstDash val="solid"/>
-                    </a:lnB>
-                    <a:solidFill>
-                      <a:srgbClr val="FFFEF8"/>
-                    </a:solidFill>
-                  </a:tcPr>
-                </a:tc>
-              </a:tr>
-              <a:tr h="420624">
-                <a:tc>
-                  <a:txBody>
-                    <a:bodyPr wrap="square">
-                      <a:noAutofit/>
-                    </a:bodyPr>
-                    <a:lstStyle/>
-                    <a:p>
-                      <a:pPr algn="l">
-                        <a:lnSpc>
-                          <a:spcPts val="2127"/>
-                        </a:lnSpc>
-                        <a:buNone/>
-                        <a:defRPr sz="1850" b="0">
-                          <a:solidFill>
-                            <a:srgbClr val="303437"/>
-                          </a:solidFill>
-                          <a:latin typeface="Noto Sans"/>
-                        </a:defRPr>
-                      </a:pPr>
-                      <a:r>
-                        <a:rPr sz="1850" b="0" lang="ja-JP" altLang="en-US">
-                          <a:solidFill>
-                            <a:srgbClr val="303437"/>
-                          </a:solidFill>
-                          <a:latin typeface="Noto Sans"/>
-                          <a:ea typeface="Noto Sans CJK JP"/>
-                          <a:cs typeface="Noto Sans"/>
-                        </a:rPr>
-                        <a:t>text-davinci-003 (2022)</a:t>
-                      </a:r>
-                    </a:p>
-                  </a:txBody>
-                  <a:tcPr marL="63500" marR="63500" marT="38100" marB="38100" anchor="ctr">
-                    <a:lnL w="7620">
-                      <a:noFill/>
-                    </a:lnL>
-                    <a:lnR w="7620">
-                      <a:noFill/>
-                    </a:lnR>
-                    <a:lnT w="7620">
-                      <a:solidFill>
-                        <a:srgbClr val="626669"/>
-                      </a:solidFill>
-                      <a:prstDash val="solid"/>
-                    </a:lnT>
-                    <a:lnB w="7620">
-                      <a:noFill/>
-                    </a:lnB>
-                    <a:solidFill>
-                      <a:srgbClr val="FFFEF8"/>
-                    </a:solidFill>
-                  </a:tcPr>
-                </a:tc>
-                <a:tc>
-                  <a:txBody>
-                    <a:bodyPr wrap="square">
-                      <a:noAutofit/>
-                    </a:bodyPr>
-                    <a:lstStyle/>
-                    <a:p>
-                      <a:pPr algn="r">
-                        <a:lnSpc>
-                          <a:spcPts val="2127"/>
-                        </a:lnSpc>
-                        <a:buNone/>
-                        <a:defRPr sz="1850" b="0">
-                          <a:solidFill>
-                            <a:srgbClr val="303437"/>
-                          </a:solidFill>
-                          <a:latin typeface="Noto Sans"/>
-                        </a:defRPr>
-                      </a:pPr>
-                      <a:r>
-                        <a:rPr sz="1850" b="0" lang="ja-JP" altLang="en-US">
-                          <a:solidFill>
-                            <a:srgbClr val="303437"/>
-                          </a:solidFill>
-                          <a:latin typeface="Noto Sans"/>
-                          <a:ea typeface="Noto Sans CJK JP"/>
-                          <a:cs typeface="Noto Sans"/>
-                        </a:rPr>
-                        <a:t>0.5551</a:t>
-                      </a:r>
-                    </a:p>
-                  </a:txBody>
-                  <a:tcPr marL="63500" marR="63500" marT="38100" marB="38100" anchor="ctr">
-                    <a:lnL w="7620">
-                      <a:noFill/>
-                    </a:lnL>
-                    <a:lnR w="7620">
-                      <a:noFill/>
-                    </a:lnR>
-                    <a:lnT w="7620">
-                      <a:solidFill>
-                        <a:srgbClr val="626669"/>
-                      </a:solidFill>
-                      <a:prstDash val="solid"/>
-                    </a:lnT>
-                    <a:lnB w="7620">
-                      <a:noFill/>
-                    </a:lnB>
-                    <a:solidFill>
-                      <a:srgbClr val="FFFEF8"/>
-                    </a:solidFill>
-                  </a:tcPr>
-                </a:tc>
-                <a:tc>
-                  <a:txBody>
-                    <a:bodyPr wrap="square">
-                      <a:noAutofit/>
-                    </a:bodyPr>
-                    <a:lstStyle/>
-                    <a:p>
-                      <a:pPr algn="r">
-                        <a:lnSpc>
-                          <a:spcPts val="2127"/>
-                        </a:lnSpc>
-                        <a:buNone/>
-                        <a:defRPr sz="1850" b="0">
-                          <a:solidFill>
-                            <a:srgbClr val="303437"/>
-                          </a:solidFill>
-                          <a:latin typeface="Noto Sans"/>
-                        </a:defRPr>
-                      </a:pPr>
-                      <a:r>
-                        <a:rPr sz="1850" b="0" lang="ja-JP" altLang="en-US">
-                          <a:solidFill>
-                            <a:srgbClr val="303437"/>
-                          </a:solidFill>
-                          <a:latin typeface="Noto Sans"/>
-                          <a:ea typeface="Noto Sans CJK JP"/>
-                          <a:cs typeface="Noto Sans"/>
-                        </a:rPr>
-                        <a:t>0.2045</a:t>
-                      </a:r>
-                    </a:p>
-                  </a:txBody>
-                  <a:tcPr marL="63500" marR="63500" marT="38100" marB="38100" anchor="ctr">
-                    <a:lnL w="7620">
-                      <a:noFill/>
-                    </a:lnL>
-                    <a:lnR w="7620">
-                      <a:noFill/>
-                    </a:lnR>
-                    <a:lnT w="7620">
-                      <a:solidFill>
-                        <a:srgbClr val="626669"/>
-                      </a:solidFill>
-                      <a:prstDash val="solid"/>
-                    </a:lnT>
-                    <a:lnB w="7620">
-                      <a:noFill/>
-                    </a:lnB>
-                    <a:solidFill>
-                      <a:srgbClr val="FFFEF8"/>
-                    </a:solidFill>
-                  </a:tcPr>
-                </a:tc>
-                <a:tc>
-                  <a:txBody>
-                    <a:bodyPr wrap="square">
-                      <a:noAutofit/>
-                    </a:bodyPr>
-                    <a:lstStyle/>
-                    <a:p>
-                      <a:pPr algn="r">
-                        <a:lnSpc>
-                          <a:spcPts val="2127"/>
-                        </a:lnSpc>
-                        <a:buNone/>
-                        <a:defRPr sz="1850" b="0">
-                          <a:solidFill>
-                            <a:srgbClr val="303437"/>
-                          </a:solidFill>
-                          <a:latin typeface="Noto Sans"/>
-                        </a:defRPr>
-                      </a:pPr>
-                      <a:r>
-                        <a:rPr sz="1850" b="0" lang="ja-JP" altLang="en-US">
-                          <a:solidFill>
-                            <a:srgbClr val="303437"/>
-                          </a:solidFill>
-                          <a:latin typeface="Noto Sans"/>
-                          <a:ea typeface="Noto Sans CJK JP"/>
-                          <a:cs typeface="Noto Sans"/>
-                        </a:rPr>
-                        <a:t>0.5573</a:t>
-                      </a:r>
-                    </a:p>
-                  </a:txBody>
-                  <a:tcPr marL="63500" marR="63500" marT="38100" marB="38100" anchor="ctr">
-                    <a:lnL w="7620">
-                      <a:noFill/>
-                    </a:lnL>
-                    <a:lnR w="7620">
-                      <a:noFill/>
-                    </a:lnR>
-                    <a:lnT w="7620">
-                      <a:solidFill>
-                        <a:srgbClr val="626669"/>
-                      </a:solidFill>
-                      <a:prstDash val="solid"/>
-                    </a:lnT>
-                    <a:lnB w="7620">
-                      <a:noFill/>
-                    </a:lnB>
-                    <a:solidFill>
-                      <a:srgbClr val="FFFEF8"/>
-                    </a:solidFill>
-                  </a:tcPr>
-                </a:tc>
-              </a:tr>
-              <a:tr h="420624">
-                <a:tc>
-                  <a:txBody>
-                    <a:bodyPr wrap="square">
-                      <a:noAutofit/>
-                    </a:bodyPr>
-                    <a:lstStyle/>
-                    <a:p>
-                      <a:pPr algn="l">
-                        <a:lnSpc>
-                          <a:spcPts val="2127"/>
-                        </a:lnSpc>
-                        <a:buNone/>
-                        <a:defRPr sz="1850" b="0">
-                          <a:solidFill>
-                            <a:srgbClr val="303437"/>
-                          </a:solidFill>
-                          <a:latin typeface="Noto Sans"/>
-                        </a:defRPr>
-                      </a:pPr>
-                      <a:r>
-                        <a:rPr sz="1850" b="0" lang="ja-JP" altLang="en-US">
-                          <a:solidFill>
-                            <a:srgbClr val="303437"/>
-                          </a:solidFill>
-                          <a:latin typeface="Noto Sans"/>
-                          <a:ea typeface="Noto Sans CJK JP"/>
-                          <a:cs typeface="Noto Sans"/>
-                        </a:rPr>
-                        <a:t>BLOOM (2022)</a:t>
-                      </a:r>
-                    </a:p>
-                  </a:txBody>
-                  <a:tcPr marL="63500" marR="63500" marT="38100" marB="38100" anchor="ctr">
-                    <a:lnL w="7620">
-                      <a:noFill/>
-                    </a:lnL>
-                    <a:lnR w="7620">
-                      <a:noFill/>
-                    </a:lnR>
-                    <a:lnT w="7620">
-                      <a:noFill/>
-                    </a:lnT>
-                    <a:lnB w="7620">
-                      <a:noFill/>
-                    </a:lnB>
-                    <a:solidFill>
-                      <a:srgbClr val="FFFEF8"/>
-                    </a:solidFill>
-                  </a:tcPr>
-                </a:tc>
-                <a:tc>
-                  <a:txBody>
-                    <a:bodyPr wrap="square">
-                      <a:noAutofit/>
-                    </a:bodyPr>
-                    <a:lstStyle/>
-                    <a:p>
-                      <a:pPr algn="r">
-                        <a:lnSpc>
-                          <a:spcPts val="2127"/>
-                        </a:lnSpc>
-                        <a:buNone/>
-                        <a:defRPr sz="1850" b="0">
-                          <a:solidFill>
-                            <a:srgbClr val="303437"/>
-                          </a:solidFill>
-                          <a:latin typeface="Noto Sans"/>
-                        </a:defRPr>
-                      </a:pPr>
-                      <a:r>
-                        <a:rPr sz="1850" b="0" lang="ja-JP" altLang="en-US">
-                          <a:solidFill>
-                            <a:srgbClr val="303437"/>
-                          </a:solidFill>
-                          <a:latin typeface="Noto Sans"/>
-                          <a:ea typeface="Noto Sans CJK JP"/>
-                          <a:cs typeface="Noto Sans"/>
-                        </a:rPr>
-                        <a:t>0.5773</a:t>
-                      </a:r>
-                    </a:p>
-                  </a:txBody>
-                  <a:tcPr marL="63500" marR="63500" marT="38100" marB="38100" anchor="ctr">
-                    <a:lnL w="7620">
-                      <a:noFill/>
-                    </a:lnL>
-                    <a:lnR w="7620">
-                      <a:noFill/>
-                    </a:lnR>
-                    <a:lnT w="7620">
-                      <a:noFill/>
-                    </a:lnT>
-                    <a:lnB w="7620">
-                      <a:noFill/>
-                    </a:lnB>
-                    <a:solidFill>
-                      <a:srgbClr val="FFFEF8"/>
-                    </a:solidFill>
-                  </a:tcPr>
-                </a:tc>
-                <a:tc>
-                  <a:txBody>
-                    <a:bodyPr wrap="square">
-                      <a:noAutofit/>
-                    </a:bodyPr>
-                    <a:lstStyle/>
-                    <a:p>
-                      <a:pPr algn="r">
-                        <a:lnSpc>
-                          <a:spcPts val="2127"/>
-                        </a:lnSpc>
-                        <a:buNone/>
-                        <a:defRPr sz="1850" b="0">
-                          <a:solidFill>
-                            <a:srgbClr val="303437"/>
-                          </a:solidFill>
-                          <a:latin typeface="Noto Sans"/>
-                        </a:defRPr>
-                      </a:pPr>
-                      <a:r>
-                        <a:rPr sz="1850" b="0" lang="ja-JP" altLang="en-US">
-                          <a:solidFill>
-                            <a:srgbClr val="303437"/>
-                          </a:solidFill>
-                          <a:latin typeface="Noto Sans"/>
-                          <a:ea typeface="Noto Sans CJK JP"/>
-                          <a:cs typeface="Noto Sans"/>
-                        </a:rPr>
-                        <a:t>0.2689</a:t>
-                      </a:r>
-                    </a:p>
-                  </a:txBody>
-                  <a:tcPr marL="63500" marR="63500" marT="38100" marB="38100" anchor="ctr">
-                    <a:lnL w="7620">
-                      <a:noFill/>
-                    </a:lnL>
-                    <a:lnR w="7620">
-                      <a:noFill/>
-                    </a:lnR>
-                    <a:lnT w="7620">
-                      <a:noFill/>
-                    </a:lnT>
-                    <a:lnB w="7620">
-                      <a:noFill/>
-                    </a:lnB>
-                    <a:solidFill>
-                      <a:srgbClr val="FFFEF8"/>
-                    </a:solidFill>
-                  </a:tcPr>
-                </a:tc>
-                <a:tc>
-                  <a:txBody>
-                    <a:bodyPr wrap="square">
-                      <a:noAutofit/>
-                    </a:bodyPr>
-                    <a:lstStyle/>
-                    <a:p>
-                      <a:pPr algn="r">
-                        <a:lnSpc>
-                          <a:spcPts val="2127"/>
-                        </a:lnSpc>
-                        <a:buNone/>
-                        <a:defRPr sz="1850" b="0">
-                          <a:solidFill>
-                            <a:srgbClr val="303437"/>
-                          </a:solidFill>
-                          <a:latin typeface="Noto Sans"/>
-                        </a:defRPr>
-                      </a:pPr>
-                      <a:r>
-                        <a:rPr sz="1850" b="0" lang="ja-JP" altLang="en-US">
-                          <a:solidFill>
-                            <a:srgbClr val="303437"/>
-                          </a:solidFill>
-                          <a:latin typeface="Noto Sans"/>
-                          <a:ea typeface="Noto Sans CJK JP"/>
-                          <a:cs typeface="Noto Sans"/>
-                        </a:rPr>
-                        <a:t>0.5879</a:t>
-                      </a:r>
-                    </a:p>
-                  </a:txBody>
-                  <a:tcPr marL="63500" marR="63500" marT="38100" marB="38100" anchor="ctr">
-                    <a:lnL w="7620">
-                      <a:noFill/>
-                    </a:lnL>
-                    <a:lnR w="7620">
-                      <a:noFill/>
-                    </a:lnR>
-                    <a:lnT w="7620">
-                      <a:noFill/>
-                    </a:lnT>
-                    <a:lnB w="7620">
-                      <a:noFill/>
-                    </a:lnB>
-                    <a:solidFill>
-                      <a:srgbClr val="FFFEF8"/>
-                    </a:solidFill>
-                  </a:tcPr>
-                </a:tc>
-              </a:tr>
-              <a:tr h="420624">
-                <a:tc>
-                  <a:txBody>
-                    <a:bodyPr wrap="square">
-                      <a:noAutofit/>
-                    </a:bodyPr>
-                    <a:lstStyle/>
-                    <a:p>
-                      <a:pPr algn="l">
-                        <a:lnSpc>
-                          <a:spcPts val="2127"/>
-                        </a:lnSpc>
-                        <a:buNone/>
-                        <a:defRPr sz="1850" b="0">
-                          <a:solidFill>
-                            <a:srgbClr val="303437"/>
-                          </a:solidFill>
-                          <a:latin typeface="Noto Sans"/>
-                        </a:defRPr>
-                      </a:pPr>
-                      <a:r>
-                        <a:rPr sz="1850" b="0" lang="ja-JP" altLang="en-US">
-                          <a:solidFill>
-                            <a:srgbClr val="303437"/>
-                          </a:solidFill>
-                          <a:latin typeface="Noto Sans"/>
-                          <a:ea typeface="Noto Sans CJK JP"/>
-                          <a:cs typeface="Noto Sans"/>
-                        </a:rPr>
-                        <a:t>OPT-175B (2022)</a:t>
-                      </a:r>
-                    </a:p>
-                  </a:txBody>
-                  <a:tcPr marL="63500" marR="63500" marT="38100" marB="38100" anchor="ctr">
-                    <a:lnL w="7620">
-                      <a:noFill/>
-                    </a:lnL>
-                    <a:lnR w="7620">
-                      <a:noFill/>
-                    </a:lnR>
-                    <a:lnT w="7620">
-                      <a:noFill/>
-                    </a:lnT>
-                    <a:lnB w="15240">
-                      <a:solidFill>
-                        <a:srgbClr val="626669"/>
-                      </a:solidFill>
-                      <a:prstDash val="solid"/>
-                    </a:lnB>
-                    <a:solidFill>
-                      <a:srgbClr val="FFFEF8"/>
-                    </a:solidFill>
-                  </a:tcPr>
-                </a:tc>
-                <a:tc>
-                  <a:txBody>
-                    <a:bodyPr wrap="square">
-                      <a:noAutofit/>
-                    </a:bodyPr>
-                    <a:lstStyle/>
-                    <a:p>
-                      <a:pPr algn="r">
-                        <a:lnSpc>
-                          <a:spcPts val="2127"/>
-                        </a:lnSpc>
-                        <a:buNone/>
-                        <a:defRPr sz="1850" b="0">
-                          <a:solidFill>
-                            <a:srgbClr val="303437"/>
-                          </a:solidFill>
-                          <a:latin typeface="Noto Sans"/>
-                        </a:defRPr>
-                      </a:pPr>
-                      <a:r>
-                        <a:rPr sz="1850" b="0" lang="ja-JP" altLang="en-US">
-                          <a:solidFill>
-                            <a:srgbClr val="303437"/>
-                          </a:solidFill>
-                          <a:latin typeface="Noto Sans"/>
-                          <a:ea typeface="Noto Sans CJK JP"/>
-                          <a:cs typeface="Noto Sans"/>
-                        </a:rPr>
-                        <a:t>0.7296</a:t>
-                      </a:r>
-                    </a:p>
-                  </a:txBody>
-                  <a:tcPr marL="63500" marR="63500" marT="38100" marB="38100" anchor="ctr">
-                    <a:lnL w="7620">
-                      <a:noFill/>
-                    </a:lnL>
-                    <a:lnR w="7620">
-                      <a:noFill/>
-                    </a:lnR>
-                    <a:lnT w="7620">
-                      <a:noFill/>
-                    </a:lnT>
-                    <a:lnB w="15240">
-                      <a:solidFill>
-                        <a:srgbClr val="626669"/>
-                      </a:solidFill>
-                      <a:prstDash val="solid"/>
-                    </a:lnB>
-                    <a:solidFill>
-                      <a:srgbClr val="FFFEF8"/>
-                    </a:solidFill>
-                  </a:tcPr>
-                </a:tc>
-                <a:tc>
-                  <a:txBody>
-                    <a:bodyPr wrap="square">
-                      <a:noAutofit/>
-                    </a:bodyPr>
-                    <a:lstStyle/>
-                    <a:p>
-                      <a:pPr algn="r">
-                        <a:lnSpc>
-                          <a:spcPts val="2127"/>
-                        </a:lnSpc>
-                        <a:buNone/>
-                        <a:defRPr sz="1850" b="0">
-                          <a:solidFill>
-                            <a:srgbClr val="303437"/>
-                          </a:solidFill>
-                          <a:latin typeface="Noto Sans"/>
-                        </a:defRPr>
-                      </a:pPr>
-                      <a:r>
-                        <a:rPr sz="1850" b="0" lang="ja-JP" altLang="en-US">
-                          <a:solidFill>
-                            <a:srgbClr val="303437"/>
-                          </a:solidFill>
-                          <a:latin typeface="Noto Sans"/>
-                          <a:ea typeface="Noto Sans CJK JP"/>
-                          <a:cs typeface="Noto Sans"/>
-                        </a:rPr>
-                        <a:t>0.4434</a:t>
-                      </a:r>
-                    </a:p>
-                  </a:txBody>
-                  <a:tcPr marL="63500" marR="63500" marT="38100" marB="38100" anchor="ctr">
-                    <a:lnL w="7620">
-                      <a:noFill/>
-                    </a:lnL>
-                    <a:lnR w="7620">
-                      <a:noFill/>
-                    </a:lnR>
-                    <a:lnT w="7620">
-                      <a:noFill/>
-                    </a:lnT>
-                    <a:lnB w="15240">
-                      <a:solidFill>
-                        <a:srgbClr val="626669"/>
-                      </a:solidFill>
-                      <a:prstDash val="solid"/>
-                    </a:lnB>
-                    <a:solidFill>
-                      <a:srgbClr val="FFFEF8"/>
-                    </a:solidFill>
-                  </a:tcPr>
-                </a:tc>
-                <a:tc>
-                  <a:txBody>
-                    <a:bodyPr wrap="square">
-                      <a:noAutofit/>
-                    </a:bodyPr>
-                    <a:lstStyle/>
-                    <a:p>
-                      <a:pPr algn="r">
-                        <a:lnSpc>
-                          <a:spcPts val="2127"/>
-                        </a:lnSpc>
-                        <a:buNone/>
-                        <a:defRPr sz="1850" b="0">
-                          <a:solidFill>
-                            <a:srgbClr val="303437"/>
-                          </a:solidFill>
-                          <a:latin typeface="Noto Sans"/>
-                        </a:defRPr>
-                      </a:pPr>
-                      <a:r>
-                        <a:rPr sz="1850" b="0" lang="ja-JP" altLang="en-US">
-                          <a:solidFill>
-                            <a:srgbClr val="303437"/>
-                          </a:solidFill>
-                          <a:latin typeface="Noto Sans"/>
-                          <a:ea typeface="Noto Sans CJK JP"/>
-                          <a:cs typeface="Noto Sans"/>
-                        </a:rPr>
-                        <a:t>0.5522</a:t>
-                      </a:r>
-                    </a:p>
-                  </a:txBody>
-                  <a:tcPr marL="63500" marR="63500" marT="38100" marB="38100" anchor="ctr">
-                    <a:lnL w="7620">
-                      <a:noFill/>
-                    </a:lnL>
-                    <a:lnR w="7620">
-                      <a:noFill/>
-                    </a:lnR>
-                    <a:lnT w="7620">
-                      <a:noFill/>
-                    </a:lnT>
-                    <a:lnB w="15240">
-                      <a:solidFill>
-                        <a:srgbClr val="626669"/>
-                      </a:solidFill>
-                      <a:prstDash val="solid"/>
-                    </a:lnB>
-                    <a:solidFill>
-                      <a:srgbClr val="FFFEF8"/>
-                    </a:solidFill>
-                  </a:tcPr>
-                </a:tc>
-              </a:tr>
-            </a:tbl>
-          </a:graphicData>
-        </a:graphic>
-      </p:graphicFrame>
-      <p:sp>
-        <p:nvSpPr>
-          <p:cNvPr id="5" name="TextBox 4"/>
-          <p:cNvSpPr txBox="1"/>
-          <p:nvPr/>
-        </p:nvSpPr>
-        <p:spPr>
-          <a:xfrm>
-            <a:off x="594360" y="3392424"/>
-            <a:ext cx="7955279" cy="658368"/>
-          </a:xfrm>
-          <a:prstGeom prst="rect">
-            <a:avLst/>
-          </a:prstGeom>
-          <a:noFill/>
-        </p:spPr>
-        <p:txBody>
-          <a:bodyPr wrap="square" lIns="0" rIns="0" tIns="0" bIns="0">
-            <a:noAutofit/>
-          </a:bodyPr>
-          <a:lstStyle/>
-          <a:p>
-            <a:pPr algn="l">
-              <a:lnSpc>
-                <a:spcPts val="2047"/>
-              </a:lnSpc>
-              <a:spcBef>
-                <a:spcPts val="0"/>
-              </a:spcBef>
-              <a:spcAft>
-                <a:spcPts val="0"/>
-              </a:spcAft>
-              <a:buNone/>
-              <a:defRPr sz="1750" b="0">
-                <a:solidFill>
-                  <a:srgbClr val="303437"/>
-                </a:solidFill>
-                <a:latin typeface="Noto Sans"/>
-              </a:defRPr>
-            </a:pPr>
-            <a:r>
-              <a:rPr sz="1750" b="0" lang="ja-JP" altLang="en-US">
-                <a:solidFill>
-                  <a:srgbClr val="303437"/>
-                </a:solidFill>
-                <a:latin typeface="Noto Sans"/>
-                <a:ea typeface="Noto Sans CJK JP"/>
-                <a:cs typeface="Noto Sans"/>
-              </a:rPr>
-              <a:t>HELM Classicで2023年に公開された結果。各1試行でArXivは238文書、他は各1,000文書。モデルごとの文脈長で本文を分割して採点した。</a:t>
-            </a:r>
-          </a:p>
-        </p:txBody>
-      </p:sp>
-      <p:sp>
-        <p:nvSpPr>
-          <p:cNvPr id="6" name="sources"/>
-          <p:cNvSpPr txBox="1"/>
-          <p:nvPr/>
-        </p:nvSpPr>
-        <p:spPr>
-          <a:xfrm>
-            <a:off x="502920" y="4700016"/>
-            <a:ext cx="8183879" cy="530352"/>
-          </a:xfrm>
-          <a:prstGeom prst="rect">
-            <a:avLst/>
-          </a:prstGeom>
-          <a:noFill/>
-        </p:spPr>
-        <p:txBody>
-          <a:bodyPr wrap="square" lIns="0" rIns="0" tIns="0" bIns="0">
-            <a:noAutofit/>
-          </a:bodyPr>
-          <a:lstStyle/>
-          <a:p>
-            <a:pPr algn="l">
-              <a:lnSpc>
-                <a:spcPts val="940"/>
-              </a:lnSpc>
-              <a:spcBef>
-                <a:spcPts val="0"/>
-              </a:spcBef>
-              <a:spcAft>
-                <a:spcPts val="140"/>
-              </a:spcAft>
-              <a:buNone/>
-              <a:defRPr sz="810" b="0">
-                <a:solidFill>
-                  <a:srgbClr val="303437"/>
-                </a:solidFill>
-                <a:latin typeface="Noto Sans"/>
-              </a:defRPr>
-            </a:pPr>
-            <a:r>
-              <a:rPr sz="810" b="0" lang="ja-JP" altLang="en-US">
-                <a:solidFill>
-                  <a:srgbClr val="626669"/>
-                </a:solidFill>
-                <a:latin typeface="Noto Sans"/>
-                <a:ea typeface="Noto Sans CJK JP"/>
-                <a:cs typeface="Noto Sans"/>
-              </a:rPr>
-              <a:t>[1] Liang et al. (2023). Holistic Evaluation of Language Models. TMLR.</a:t>
-            </a:r>
-            <a:r>
-              <a:rPr sz="810" b="0" lang="ja-JP" altLang="en-US">
-                <a:solidFill>
-                  <a:srgbClr val="626669"/>
-                </a:solidFill>
-                <a:latin typeface="Noto Sans"/>
-                <a:ea typeface="Noto Sans CJK JP"/>
-                <a:cs typeface="Noto Sans"/>
-              </a:rPr>
-              <a:t>  </a:t>
-            </a:r>
-            <a:r>
-              <a:rPr sz="810" b="0" lang="ja-JP" altLang="en-US">
-                <a:solidFill>
-                  <a:srgbClr val="626669"/>
-                </a:solidFill>
-                <a:latin typeface="Noto Sans"/>
-                <a:ea typeface="Noto Sans CJK JP"/>
-                <a:cs typeface="Noto Sans"/>
-                <a:hlinkClick r:id="rId2"/>
-              </a:rPr>
-              <a:t>https://arxiv.org/abs/2211.09110</a:t>
             </a:r>
           </a:p>
         </p:txBody>
@@ -13740,331 +12285,6 @@
 </p:sld>
 </file>
 
-<file path=ppt/slides/slide20.xml><?xml version="1.0" encoding="utf-8"?>
-<p:sld xmlns:a="http://schemas.openxmlformats.org/drawingml/2006/main" xmlns:p="http://schemas.openxmlformats.org/presentationml/2006/main" xmlns:r="http://schemas.openxmlformats.org/officeDocument/2006/relationships">
-  <p:cSld>
-    <p:spTree>
-      <p:nvGrpSpPr>
-        <p:cNvPr id="1" name=""/>
-        <p:cNvGrpSpPr/>
-        <p:nvPr/>
-      </p:nvGrpSpPr>
-      <p:grpSpPr/>
-      <p:sp>
-        <p:nvSpPr>
-          <p:cNvPr id="2" name="Title 1"/>
-          <p:cNvSpPr>
-            <a:spLocks noGrp="1"/>
-          </p:cNvSpPr>
-          <p:nvPr>
-            <p:ph type="title"/>
-          </p:nvPr>
-        </p:nvSpPr>
-        <p:spPr>
-          <a:xfrm>
-            <a:off x="468172" y="650138"/>
-            <a:ext cx="8206740" cy="616305"/>
-          </a:xfrm>
-        </p:spPr>
-        <p:txBody>
-          <a:bodyPr wrap="square" lIns="0" rIns="0" tIns="0" bIns="0">
-            <a:noAutofit/>
-          </a:bodyPr>
-          <a:lstStyle/>
-          <a:p>
-            <a:pPr algn="l">
-              <a:lnSpc>
-                <a:spcPct val="110000"/>
-              </a:lnSpc>
-              <a:buNone/>
-              <a:defRPr sz="2800" b="0">
-                <a:solidFill>
-                  <a:srgbClr val="303437"/>
-                </a:solidFill>
-                <a:latin typeface="Noto Sans"/>
-              </a:defRPr>
-            </a:pPr>
-            <a:r>
-              <a:rPr sz="2800" b="1" lang="ja-JP" altLang="en-US">
-                <a:solidFill>
-                  <a:srgbClr val="303437"/>
-                </a:solidFill>
-                <a:latin typeface="Noto Sans"/>
-                <a:ea typeface="Noto Sans CJK JP"/>
-                <a:cs typeface="Noto Sans"/>
-              </a:rPr>
-              <a:t>評価条件まで合わせて損失を読む</a:t>
-            </a:r>
-          </a:p>
-        </p:txBody>
-      </p:sp>
-      <p:sp>
-        <p:nvSpPr>
-          <p:cNvPr id="3" name="Text Placeholder 2"/>
-          <p:cNvSpPr>
-            <a:spLocks noGrp="1"/>
-          </p:cNvSpPr>
-          <p:nvPr>
-            <p:ph type="body" idx="1"/>
-          </p:nvPr>
-        </p:nvSpPr>
-        <p:spPr>
-          <a:xfrm>
-            <a:off x="594360" y="1463040"/>
-            <a:ext cx="7955279" cy="3044952"/>
-          </a:xfrm>
-        </p:spPr>
-        <p:txBody>
-          <a:bodyPr wrap="square" tIns="91440" bIns="91440">
-            <a:noAutofit/>
-          </a:bodyPr>
-          <a:lstStyle/>
-          <a:p>
-            <a:pPr marL="457200" indent="-355600">
-              <a:lnSpc>
-                <a:spcPts val="2379"/>
-              </a:lnSpc>
-              <a:spcAft>
-                <a:spcPts val="700"/>
-              </a:spcAft>
-              <a:buSzPct val="66500"/>
-              <a:buFont typeface="Noto Sans CJK JP"/>
-              <a:buChar char="●"/>
-              <a:defRPr sz="2000" b="0">
-                <a:solidFill>
-                  <a:srgbClr val="303437"/>
-                </a:solidFill>
-                <a:latin typeface="Noto Sans"/>
-              </a:defRPr>
-            </a:pPr>
-            <a:r>
-              <a:rPr sz="2000" b="0" lang="ja-JP" altLang="en-US">
-                <a:solidFill>
-                  <a:srgbClr val="303437"/>
-                </a:solidFill>
-                <a:latin typeface="Noto Sans"/>
-                <a:ea typeface="Noto Sans CJK JP"/>
-                <a:cs typeface="Noto Sans"/>
-              </a:rPr>
-              <a:t>ArXivではtext-davinci-003のBPBが0.5551、BLOOMが0.5773。Githubでもtext-davinci-003が小さく、WikipediaではOPT-175Bが0.5522と最小だった。</a:t>
-            </a:r>
-          </a:p>
-          <a:p>
-            <a:pPr marL="457200" indent="-355600">
-              <a:lnSpc>
-                <a:spcPts val="2379"/>
-              </a:lnSpc>
-              <a:spcAft>
-                <a:spcPts val="700"/>
-              </a:spcAft>
-              <a:buSzPct val="66500"/>
-              <a:buFont typeface="Noto Sans CJK JP"/>
-              <a:buChar char="●"/>
-              <a:defRPr sz="2000" b="0">
-                <a:solidFill>
-                  <a:srgbClr val="303437"/>
-                </a:solidFill>
-                <a:latin typeface="Noto Sans"/>
-              </a:defRPr>
-            </a:pPr>
-            <a:r>
-              <a:rPr sz="2000" b="0" lang="ja-JP" altLang="en-US">
-                <a:solidFill>
-                  <a:srgbClr val="303437"/>
-                </a:solidFill>
-                <a:latin typeface="Noto Sans"/>
-                <a:ea typeface="Noto Sans CJK JP"/>
-                <a:cs typeface="Noto Sans"/>
-              </a:rPr>
-              <a:t>同じテスト文書でも、モデルによってトークンの切り方や使える文脈長が異なる。長文を複数の窓に分けて採点するため、得点には文章の分野に加えて、こうした評価条件も影響する。</a:t>
-            </a:r>
-          </a:p>
-        </p:txBody>
-      </p:sp>
-      <p:sp>
-        <p:nvSpPr>
-          <p:cNvPr id="4" name="Title 3"/>
-          <p:cNvSpPr>
-            <a:spLocks noGrp="1"/>
-          </p:cNvSpPr>
-          <p:nvPr>
-            <p:ph type="title" idx="2"/>
-          </p:nvPr>
-        </p:nvSpPr>
-        <p:spPr>
-          <a:xfrm>
-            <a:off x="75895" y="0"/>
-            <a:ext cx="8115300" cy="480060"/>
-          </a:xfrm>
-        </p:spPr>
-        <p:txBody>
-          <a:bodyPr wrap="square" lIns="0" rIns="0" tIns="0" bIns="0" anchor="ctr">
-            <a:noAutofit/>
-          </a:bodyPr>
-          <a:lstStyle/>
-          <a:p>
-            <a:pPr algn="l">
-              <a:lnSpc>
-                <a:spcPct val="110000"/>
-              </a:lnSpc>
-              <a:buNone/>
-              <a:defRPr sz="1400" b="0">
-                <a:solidFill>
-                  <a:srgbClr val="303437"/>
-                </a:solidFill>
-                <a:latin typeface="Noto Sans"/>
-              </a:defRPr>
-            </a:pPr>
-            <a:r>
-              <a:rPr sz="1400" b="1" lang="ja-JP" altLang="en-US">
-                <a:solidFill>
-                  <a:srgbClr val="FFFEF8"/>
-                </a:solidFill>
-                <a:latin typeface="Noto Sans"/>
-                <a:ea typeface="Noto Sans CJK JP"/>
-                <a:cs typeface="Noto Sans"/>
-              </a:rPr>
-              <a:t>3. 学習効果とHELMでの評価</a:t>
-            </a:r>
-          </a:p>
-        </p:txBody>
-      </p:sp>
-      <p:sp>
-        <p:nvSpPr>
-          <p:cNvPr id="5" name="sources"/>
-          <p:cNvSpPr txBox="1"/>
-          <p:nvPr/>
-        </p:nvSpPr>
-        <p:spPr>
-          <a:xfrm>
-            <a:off x="502920" y="4700016"/>
-            <a:ext cx="8183879" cy="530352"/>
-          </a:xfrm>
-          <a:prstGeom prst="rect">
-            <a:avLst/>
-          </a:prstGeom>
-          <a:noFill/>
-        </p:spPr>
-        <p:txBody>
-          <a:bodyPr wrap="square" lIns="0" rIns="0" tIns="0" bIns="0">
-            <a:noAutofit/>
-          </a:bodyPr>
-          <a:lstStyle/>
-          <a:p>
-            <a:pPr algn="l">
-              <a:lnSpc>
-                <a:spcPts val="940"/>
-              </a:lnSpc>
-              <a:spcBef>
-                <a:spcPts val="0"/>
-              </a:spcBef>
-              <a:spcAft>
-                <a:spcPts val="140"/>
-              </a:spcAft>
-              <a:buNone/>
-              <a:defRPr sz="810" b="0">
-                <a:solidFill>
-                  <a:srgbClr val="303437"/>
-                </a:solidFill>
-                <a:latin typeface="Noto Sans"/>
-              </a:defRPr>
-            </a:pPr>
-            <a:r>
-              <a:rPr sz="810" b="0" lang="ja-JP" altLang="en-US">
-                <a:solidFill>
-                  <a:srgbClr val="626669"/>
-                </a:solidFill>
-                <a:latin typeface="Noto Sans"/>
-                <a:ea typeface="Noto Sans CJK JP"/>
-                <a:cs typeface="Noto Sans"/>
-              </a:rPr>
-              <a:t>[1] Liang et al. (2023). Holistic Evaluation of Language Models. TMLR.</a:t>
-            </a:r>
-            <a:r>
-              <a:rPr sz="810" b="0" lang="ja-JP" altLang="en-US">
-                <a:solidFill>
-                  <a:srgbClr val="626669"/>
-                </a:solidFill>
-                <a:latin typeface="Noto Sans"/>
-                <a:ea typeface="Noto Sans CJK JP"/>
-                <a:cs typeface="Noto Sans"/>
-              </a:rPr>
-              <a:t>  </a:t>
-            </a:r>
-            <a:r>
-              <a:rPr sz="810" b="0" lang="ja-JP" altLang="en-US">
-                <a:solidFill>
-                  <a:srgbClr val="626669"/>
-                </a:solidFill>
-                <a:latin typeface="Noto Sans"/>
-                <a:ea typeface="Noto Sans CJK JP"/>
-                <a:cs typeface="Noto Sans"/>
-                <a:hlinkClick r:id="rId2"/>
-              </a:rPr>
-              <a:t>https://arxiv.org/abs/2211.09110</a:t>
-            </a:r>
-          </a:p>
-          <a:p>
-            <a:pPr>
-              <a:lnSpc>
-                <a:spcPts val="940"/>
-              </a:lnSpc>
-              <a:spcAft>
-                <a:spcPts val="140"/>
-              </a:spcAft>
-              <a:buNone/>
-              <a:defRPr sz="810" b="0">
-                <a:solidFill>
-                  <a:srgbClr val="303437"/>
-                </a:solidFill>
-                <a:latin typeface="Noto Sans"/>
-              </a:defRPr>
-            </a:pPr>
-            <a:r>
-              <a:rPr sz="810" b="0" lang="ja-JP" altLang="en-US">
-                <a:solidFill>
-                  <a:srgbClr val="626669"/>
-                </a:solidFill>
-                <a:latin typeface="Noto Sans"/>
-                <a:ea typeface="Noto Sans CJK JP"/>
-                <a:cs typeface="Noto Sans"/>
-              </a:rPr>
-              <a:t>[2] Stanford CRFM. HELM v0.4.0: ThePileScenario.</a:t>
-            </a:r>
-            <a:r>
-              <a:rPr sz="810" b="0" lang="ja-JP" altLang="en-US">
-                <a:solidFill>
-                  <a:srgbClr val="626669"/>
-                </a:solidFill>
-                <a:latin typeface="Noto Sans"/>
-                <a:ea typeface="Noto Sans CJK JP"/>
-                <a:cs typeface="Noto Sans"/>
-              </a:rPr>
-              <a:t>  </a:t>
-            </a:r>
-            <a:r>
-              <a:rPr sz="810" b="0" lang="ja-JP" altLang="en-US">
-                <a:solidFill>
-                  <a:srgbClr val="626669"/>
-                </a:solidFill>
-                <a:latin typeface="Noto Sans"/>
-                <a:ea typeface="Noto Sans CJK JP"/>
-                <a:cs typeface="Noto Sans"/>
-                <a:hlinkClick r:id="rId3"/>
-              </a:rPr>
-              <a:t>https://github.com/stanford-crfm/helm/blob/v0.4.0/src/helm/benchmark/scenarios/the_pile_scenario.py</a:t>
-            </a:r>
-          </a:p>
-        </p:txBody>
-      </p:sp>
-    </p:spTree>
-  </p:cSld>
-  <p:clrMapOvr>
-    <a:masterClrMapping/>
-  </p:clrMapOvr>
-</p:sld>
-</file>
-
 <file path=ppt/slides/slide21.xml><?xml version="1.0" encoding="utf-8"?>
 <p:sld xmlns:a="http://schemas.openxmlformats.org/drawingml/2006/main" xmlns:p="http://schemas.openxmlformats.org/presentationml/2006/main" xmlns:r="http://schemas.openxmlformats.org/officeDocument/2006/relationships">
   <p:cSld>
@@ -15025,7 +13245,7 @@
                 <a:ea typeface="Noto Sans CJK JP"/>
                 <a:cs typeface="Noto Sans"/>
               </a:rPr>
-              <a:t>内容を小さく試すには、先頭10,000文書を収めた公開サンプルpile-10kが使える。本資料の13例も、このサンプルから選んだ連続した抜粋である。</a:t>
+              <a:t>内容を小さく試すには、先頭10,000文書を収めた公開サンプルpile-10kが使える。本資料の13例も、このサンプルの本文から選んだ抜粋である。</a:t>
             </a:r>
           </a:p>
           <a:p>
@@ -15055,7 +13275,7 @@
                 <a:ea typeface="Noto Sans CJK JP"/>
                 <a:cs typeface="Noto Sans"/>
               </a:rPr>
-              <a:t>HELMの言語モデリング評価には、元のPileのテスト集合を使う。標準版・重複除去版・構成要素を除いたバージョンでは、収録文書や学習条件が変わる。</a:t>
+              <a:t>標準版・重複除去版・構成要素を除いたバージョンでは、収録文書や学習条件が変わる。利用する版と文書の出所を確かめる。</a:t>
             </a:r>
           </a:p>
         </p:txBody>
@@ -15130,60 +13350,6 @@
           </a:bodyPr>
           <a:lstStyle/>
           <a:p>
-            <a:pPr algn="l">
-              <a:lnSpc>
-                <a:spcPts val="940"/>
-              </a:lnSpc>
-              <a:spcBef>
-                <a:spcPts val="0"/>
-              </a:spcBef>
-              <a:spcAft>
-                <a:spcPts val="140"/>
-              </a:spcAft>
-              <a:buNone/>
-              <a:defRPr sz="810" b="0">
-                <a:solidFill>
-                  <a:srgbClr val="303437"/>
-                </a:solidFill>
-                <a:latin typeface="Noto Sans"/>
-              </a:defRPr>
-            </a:pPr>
-            <a:r>
-              <a:rPr sz="810" b="0" lang="ja-JP" altLang="en-US">
-                <a:solidFill>
-                  <a:srgbClr val="626669"/>
-                </a:solidFill>
-                <a:latin typeface="Noto Sans"/>
-                <a:ea typeface="Noto Sans CJK JP"/>
-                <a:cs typeface="Noto Sans"/>
-              </a:rPr>
-              <a:t>[1] Stanford CRFM. HELM v0.4.0: ThePileScenario.</a:t>
-            </a:r>
-            <a:r>
-              <a:rPr sz="810" b="0" lang="ja-JP" altLang="en-US">
-                <a:solidFill>
-                  <a:srgbClr val="626669"/>
-                </a:solidFill>
-                <a:latin typeface="Noto Sans"/>
-                <a:ea typeface="Noto Sans CJK JP"/>
-                <a:cs typeface="Noto Sans"/>
-              </a:rPr>
-              <a:t>  </a:t>
-            </a:r>
-            <a:r>
-              <a:rPr sz="810" b="0" lang="ja-JP" altLang="en-US">
-                <a:solidFill>
-                  <a:srgbClr val="626669"/>
-                </a:solidFill>
-                <a:latin typeface="Noto Sans"/>
-                <a:ea typeface="Noto Sans CJK JP"/>
-                <a:cs typeface="Noto Sans"/>
-                <a:hlinkClick r:id="rId2"/>
-              </a:rPr>
-              <a:t>https://github.com/stanford-crfm/helm/blob/v0.4.0/src/helm/benchmark/scenarios/the_pile_scenario.py</a:t>
-            </a:r>
-          </a:p>
-          <a:p>
             <a:pPr>
               <a:lnSpc>
                 <a:spcPts val="940"/>
@@ -15208,7 +13374,7 @@
                 <a:ea typeface="Noto Sans CJK JP"/>
                 <a:cs typeface="Noto Sans"/>
               </a:rPr>
-              <a:t>[2] Neel Nanda (2022). pile-10k: The first 10K elements of The Pile.</a:t>
+              <a:t>[1] Neel Nanda (2022). pile-10k: The first 10K elements of The Pile.</a:t>
             </a:r>
             <a:r>
               <a:rPr sz="810" b="0" lang="ja-JP" altLang="en-US">
@@ -15380,7 +13546,7 @@
                 <a:ea typeface="Noto Sans CJK JP"/>
                 <a:cs typeface="Noto Sans"/>
               </a:rPr>
-              <a:t>約40 GBにそろえた実験でも、Webだけの学習より幅広い分野の予測損失が改善した。HELMでは一部の構成要素を使い、本文に与える確率を分野別に評価している。</a:t>
+              <a:t>約40 GBにそろえた実験でも、Webだけの学習より幅広い分野の予測損失が改善した。文章の種類と混合比が、何を学べるかに関わる。</a:t>
             </a:r>
           </a:p>
           <a:p>
@@ -15798,7 +13964,7 @@
                 <a:ea typeface="Noto Sans CJK JP"/>
                 <a:cs typeface="Noto Sans"/>
               </a:rPr>
-              <a:t>構成要素と評価条件</a:t>
+              <a:t>構成要素と利用条件</a:t>
             </a:r>
           </a:p>
           <a:p>
@@ -17265,7 +15431,7 @@
                 <a:ea typeface="Noto Sans CJK JP"/>
                 <a:cs typeface="Noto Sans"/>
               </a:rPr>
-              <a:t>学習効果とHELMでの評価</a:t>
+              <a:t>多分野の文章で学習する効果</a:t>
             </a:r>
           </a:p>
           <a:p>
@@ -22390,7 +20556,7 @@
                 <a:ea typeface="Noto Sans CJK JP"/>
                 <a:cs typeface="Noto Sans"/>
               </a:rPr>
-              <a:t>Appendix: 2. 構成要素と評価条件</a:t>
+              <a:t>Appendix: 2. 構成要素と利用条件</a:t>
             </a:r>
           </a:p>
         </p:txBody>
@@ -24069,7 +22235,7 @@
                 <a:ea typeface="Noto Sans CJK JP"/>
                 <a:cs typeface="Noto Sans"/>
               </a:rPr>
-              <a:t>Appendix: 2. 構成要素と評価条件</a:t>
+              <a:t>Appendix: 2. 構成要素と利用条件</a:t>
             </a:r>
           </a:p>
         </p:txBody>
@@ -25862,7 +24028,7 @@
                 <a:ea typeface="Noto Sans CJK JP"/>
                 <a:cs typeface="Noto Sans"/>
               </a:rPr>
-              <a:t>Appendix: 2. 構成要素と評価条件</a:t>
+              <a:t>Appendix: 2. 構成要素と利用条件</a:t>
             </a:r>
           </a:p>
         </p:txBody>
@@ -27541,7 +25707,7 @@
                 <a:ea typeface="Noto Sans CJK JP"/>
                 <a:cs typeface="Noto Sans"/>
               </a:rPr>
-              <a:t>Appendix: 2. 構成要素と評価条件</a:t>
+              <a:t>Appendix: 2. 構成要素と利用条件</a:t>
             </a:r>
           </a:p>
         </p:txBody>
@@ -28816,7 +26982,7 @@
                 <a:ea typeface="Noto Sans CJK JP"/>
                 <a:cs typeface="Noto Sans"/>
               </a:rPr>
-              <a:t>Appendix: 2. 構成要素と評価条件</a:t>
+              <a:t>Appendix: 2. 構成要素と利用条件</a:t>
             </a:r>
           </a:p>
         </p:txBody>
@@ -29769,7 +27935,7 @@
                 <a:ea typeface="Noto Sans CJK JP"/>
                 <a:cs typeface="Noto Sans"/>
               </a:rPr>
-              <a:t>Appendix: 2. 構成要素と評価条件</a:t>
+              <a:t>Appendix: 2. 構成要素と利用条件</a:t>
             </a:r>
           </a:p>
         </p:txBody>
@@ -30722,7 +28888,7 @@
                 <a:ea typeface="Noto Sans CJK JP"/>
                 <a:cs typeface="Noto Sans"/>
               </a:rPr>
-              <a:t>Appendix: 2. 構成要素と評価条件</a:t>
+              <a:t>Appendix: 2. 構成要素と利用条件</a:t>
             </a:r>
           </a:p>
         </p:txBody>
@@ -31675,7 +29841,7 @@
                 <a:ea typeface="Noto Sans CJK JP"/>
                 <a:cs typeface="Noto Sans"/>
               </a:rPr>
-              <a:t>Appendix: 2. 構成要素と評価条件</a:t>
+              <a:t>Appendix: 2. 構成要素と利用条件</a:t>
             </a:r>
           </a:p>
         </p:txBody>
@@ -32424,7 +30590,7 @@
                 <a:ea typeface="Noto Sans CJK JP"/>
                 <a:cs typeface="Noto Sans"/>
               </a:rPr>
-              <a:t>Appendix: 2. 構成要素と評価条件</a:t>
+              <a:t>Appendix: 2. 構成要素と利用条件</a:t>
             </a:r>
           </a:p>
         </p:txBody>
@@ -34140,7 +32306,7 @@
                 <a:ea typeface="Noto Sans CJK JP"/>
                 <a:cs typeface="Noto Sans"/>
               </a:rPr>
-              <a:t>Appendix: 2. 構成要素と評価条件</a:t>
+              <a:t>Appendix: 2. 構成要素と利用条件</a:t>
             </a:r>
           </a:p>
         </p:txBody>
@@ -35856,7 +34022,7 @@
                 <a:ea typeface="Noto Sans CJK JP"/>
                 <a:cs typeface="Noto Sans"/>
               </a:rPr>
-              <a:t>Appendix: 2. 構成要素と評価条件</a:t>
+              <a:t>Appendix: 2. 構成要素と利用条件</a:t>
             </a:r>
           </a:p>
         </p:txBody>
@@ -37572,7 +35738,7 @@
                 <a:ea typeface="Noto Sans CJK JP"/>
                 <a:cs typeface="Noto Sans"/>
               </a:rPr>
-              <a:t>Appendix: 2. 構成要素と評価条件</a:t>
+              <a:t>Appendix: 2. 構成要素と利用条件</a:t>
             </a:r>
           </a:p>
         </p:txBody>
@@ -39372,7 +37538,7 @@
                 <a:ea typeface="Noto Sans CJK JP"/>
                 <a:cs typeface="Noto Sans"/>
               </a:rPr>
-              <a:t>Appendix: 2. 構成要素と評価条件</a:t>
+              <a:t>Appendix: 2. 構成要素と利用条件</a:t>
             </a:r>
           </a:p>
         </p:txBody>
@@ -39426,7 +37592,7 @@
                 <a:ea typeface="Noto Sans CJK JP"/>
                 <a:cs typeface="Noto Sans"/>
               </a:rPr>
-              <a:t>[1] Stanford CRFM. HELM v0.4.0: ThePileScenario.</a:t>
+              <a:t>[1] EleutherAI (n.d.). The Pile Replication Code. </a:t>
             </a:r>
             <a:r>
               <a:rPr sz="810" b="0" lang="ja-JP" altLang="en-US">
@@ -39436,20 +37602,9 @@
                 <a:latin typeface="Noto Sans"/>
                 <a:ea typeface="Noto Sans CJK JP"/>
                 <a:cs typeface="Noto Sans"/>
-              </a:rPr>
-              <a:t>  </a:t>
-            </a:r>
-            <a:r>
-              <a:rPr sz="810" b="0" lang="ja-JP" altLang="en-US">
-                <a:solidFill>
-                  <a:srgbClr val="626669"/>
-                </a:solidFill>
-                <a:latin typeface="Noto Sans"/>
-                <a:ea typeface="Noto Sans CJK JP"/>
-                <a:cs typeface="Noto Sans"/>
                 <a:hlinkClick r:id="rId2"/>
               </a:rPr>
-              <a:t>https://github.com/stanford-crfm/helm/blob/v0.4.0/src/helm/benchmark/scenarios/the_pile_scenario.py</a:t>
+              <a:t>https://github.com/EleutherAI/the-pile</a:t>
             </a:r>
           </a:p>
         </p:txBody>
@@ -39710,7 +37865,7 @@
                 <a:ea typeface="Noto Sans CJK JP"/>
                 <a:cs typeface="Noto Sans"/>
               </a:rPr>
-              <a:t>Appendix: 2. 構成要素と評価条件</a:t>
+              <a:t>Appendix: 2. 構成要素と利用条件</a:t>
             </a:r>
           </a:p>
         </p:txBody>
@@ -40395,7 +38550,7 @@
                 <a:ea typeface="Noto Sans CJK JP"/>
                 <a:cs typeface="Noto Sans"/>
               </a:rPr>
-              <a:t>Liang et al. (2023). Holistic Evaluation of Language Models. TMLR.</a:t>
+              <a:t>Biderman et al. (2023). Pythia: A Suite for Analyzing Large Language Models Across Training and Scaling. ICML.</a:t>
             </a:r>
           </a:p>
         </p:txBody>
@@ -40449,7 +38604,7 @@
                 <a:ea typeface="Noto Sans CJK JP"/>
                 <a:cs typeface="Noto Sans"/>
               </a:rPr>
-              <a:t>言語モデルを多様なシナリオと指標で横断評価する枠組み。The Pileは言語モデリング課題の一部となる。</a:t>
+              <a:t>同じデータ順で異なる規模のモデルを学習し、途中のチェックポイントとともに学習過程の比較基盤を公開した。</a:t>
             </a:r>
           </a:p>
         </p:txBody>
@@ -40502,9 +38657,9 @@
                 <a:latin typeface="Noto Sans"/>
                 <a:ea typeface="Noto Sans CJK JP"/>
                 <a:cs typeface="Noto Sans"/>
-                <a:hlinkClick r:id="rId2"/>
-              </a:rPr>
-              <a:t>https://arxiv.org/abs/2211.09110</a:t>
+                <a:hlinkClick r:id="rId3"/>
+              </a:rPr>
+              <a:t>https://arxiv.org/abs/2304.01373</a:t>
             </a:r>
           </a:p>
         </p:txBody>
@@ -40558,7 +38713,7 @@
                 <a:ea typeface="Noto Sans CJK JP"/>
                 <a:cs typeface="Noto Sans"/>
               </a:rPr>
-              <a:t>Biderman et al. (2023). Pythia: A Suite for Analyzing Large Language Models Across Training and Scaling. ICML.</a:t>
+              <a:t>EleutherAI (n.d.). The Pile Replication Code.（2026-10-18参照）</a:t>
             </a:r>
           </a:p>
         </p:txBody>
@@ -40612,7 +38767,7 @@
                 <a:ea typeface="Noto Sans CJK JP"/>
                 <a:cs typeface="Noto Sans"/>
               </a:rPr>
-              <a:t>同じデータ順で異なる規模のモデルを学習し、途中のチェックポイントとともに学習過程の比較基盤を公開した。</a:t>
+              <a:t>The Pileの再構築コード、各構成要素の収集実装、反復回数と容量表を公開する公式リポジトリ。</a:t>
             </a:r>
           </a:p>
         </p:txBody>
@@ -40665,9 +38820,9 @@
                 <a:latin typeface="Noto Sans"/>
                 <a:ea typeface="Noto Sans CJK JP"/>
                 <a:cs typeface="Noto Sans"/>
-                <a:hlinkClick r:id="rId3"/>
-              </a:rPr>
-              <a:t>https://arxiv.org/abs/2304.01373</a:t>
+                <a:hlinkClick r:id="rId2"/>
+              </a:rPr>
+              <a:t>https://github.com/EleutherAI/the-pile</a:t>
             </a:r>
           </a:p>
         </p:txBody>
@@ -40835,7 +38990,7 @@
                 <a:ea typeface="Noto Sans CJK JP"/>
                 <a:cs typeface="Noto Sans"/>
               </a:rPr>
-              <a:t>EleutherAI. The Pile Replication Code.</a:t>
+              <a:t>Neel Nanda (2022). pile-10k: The first 10K elements of The Pile.</a:t>
             </a:r>
           </a:p>
         </p:txBody>
@@ -40889,7 +39044,7 @@
                 <a:ea typeface="Noto Sans CJK JP"/>
                 <a:cs typeface="Noto Sans"/>
               </a:rPr>
-              <a:t>The Pileの再構築コード、各構成要素の収集実装、反復回数と容量表を公開する公式リポジトリ。</a:t>
+              <a:t>The Pileの先頭10,000文書を、デバッグ向けに公開した小規模サンプル。本文と構成要素名の形式を試せる。</a:t>
             </a:r>
           </a:p>
         </p:txBody>
@@ -40903,169 +39058,6 @@
         <p:spPr>
           <a:xfrm>
             <a:off x="594360" y="2654808"/>
-            <a:ext cx="7955279" cy="228600"/>
-          </a:xfrm>
-          <a:prstGeom prst="rect">
-            <a:avLst/>
-          </a:prstGeom>
-          <a:noFill/>
-        </p:spPr>
-        <p:txBody>
-          <a:bodyPr wrap="square" lIns="0" rIns="0" tIns="0" bIns="0">
-            <a:noAutofit/>
-          </a:bodyPr>
-          <a:lstStyle/>
-          <a:p>
-            <a:pPr algn="l">
-              <a:lnSpc>
-                <a:spcPts val="1345"/>
-              </a:lnSpc>
-              <a:spcBef>
-                <a:spcPts val="0"/>
-              </a:spcBef>
-              <a:spcAft>
-                <a:spcPts val="0"/>
-              </a:spcAft>
-              <a:buNone/>
-              <a:defRPr sz="1150" b="0">
-                <a:solidFill>
-                  <a:srgbClr val="303437"/>
-                </a:solidFill>
-                <a:latin typeface="Noto Sans"/>
-              </a:defRPr>
-            </a:pPr>
-            <a:r>
-              <a:rPr sz="1150" b="0" lang="ja-JP" altLang="en-US">
-                <a:solidFill>
-                  <a:srgbClr val="2166AC"/>
-                </a:solidFill>
-                <a:latin typeface="Noto Sans"/>
-                <a:ea typeface="Noto Sans CJK JP"/>
-                <a:cs typeface="Noto Sans"/>
-                <a:hlinkClick r:id="rId2"/>
-              </a:rPr>
-              <a:t>https://github.com/EleutherAI/the-pile</a:t>
-            </a:r>
-          </a:p>
-        </p:txBody>
-      </p:sp>
-      <p:sp>
-        <p:nvSpPr>
-          <p:cNvPr id="7" name="TextBox 6"/>
-          <p:cNvSpPr txBox="1"/>
-          <p:nvPr/>
-        </p:nvSpPr>
-        <p:spPr>
-          <a:xfrm>
-            <a:off x="594360" y="2971800"/>
-            <a:ext cx="7955279" cy="566928"/>
-          </a:xfrm>
-          <a:prstGeom prst="rect">
-            <a:avLst/>
-          </a:prstGeom>
-          <a:noFill/>
-        </p:spPr>
-        <p:txBody>
-          <a:bodyPr wrap="square" lIns="0" rIns="0" tIns="0" bIns="0">
-            <a:noAutofit/>
-          </a:bodyPr>
-          <a:lstStyle/>
-          <a:p>
-            <a:pPr algn="l">
-              <a:lnSpc>
-                <a:spcPts val="2029"/>
-              </a:lnSpc>
-              <a:spcBef>
-                <a:spcPts val="0"/>
-              </a:spcBef>
-              <a:spcAft>
-                <a:spcPts val="0"/>
-              </a:spcAft>
-              <a:buNone/>
-              <a:defRPr sz="1750" b="0">
-                <a:solidFill>
-                  <a:srgbClr val="303437"/>
-                </a:solidFill>
-                <a:latin typeface="Noto Sans"/>
-              </a:defRPr>
-            </a:pPr>
-            <a:r>
-              <a:rPr sz="1750" b="0" lang="ja-JP" altLang="en-US">
-                <a:solidFill>
-                  <a:srgbClr val="303437"/>
-                </a:solidFill>
-                <a:latin typeface="Noto Sans"/>
-                <a:ea typeface="Noto Sans CJK JP"/>
-                <a:cs typeface="Noto Sans"/>
-              </a:rPr>
-              <a:t>Neel Nanda (2022). pile-10k: The first 10K elements of The Pile.</a:t>
-            </a:r>
-          </a:p>
-        </p:txBody>
-      </p:sp>
-      <p:sp>
-        <p:nvSpPr>
-          <p:cNvPr id="8" name="TextBox 7"/>
-          <p:cNvSpPr txBox="1"/>
-          <p:nvPr/>
-        </p:nvSpPr>
-        <p:spPr>
-          <a:xfrm>
-            <a:off x="594360" y="3566160"/>
-            <a:ext cx="7955279" cy="521207"/>
-          </a:xfrm>
-          <a:prstGeom prst="rect">
-            <a:avLst/>
-          </a:prstGeom>
-          <a:noFill/>
-        </p:spPr>
-        <p:txBody>
-          <a:bodyPr wrap="square" lIns="0" rIns="0" tIns="0" bIns="0">
-            <a:noAutofit/>
-          </a:bodyPr>
-          <a:lstStyle/>
-          <a:p>
-            <a:pPr algn="l">
-              <a:lnSpc>
-                <a:spcPts val="1980"/>
-              </a:lnSpc>
-              <a:spcBef>
-                <a:spcPts val="0"/>
-              </a:spcBef>
-              <a:spcAft>
-                <a:spcPts val="0"/>
-              </a:spcAft>
-              <a:buNone/>
-              <a:defRPr sz="1650" b="0">
-                <a:solidFill>
-                  <a:srgbClr val="303437"/>
-                </a:solidFill>
-                <a:latin typeface="Noto Sans"/>
-              </a:defRPr>
-            </a:pPr>
-            <a:r>
-              <a:rPr sz="1650" b="0" lang="ja-JP" altLang="en-US">
-                <a:solidFill>
-                  <a:srgbClr val="303437"/>
-                </a:solidFill>
-                <a:latin typeface="Noto Sans"/>
-                <a:ea typeface="Noto Sans CJK JP"/>
-                <a:cs typeface="Noto Sans"/>
-              </a:rPr>
-              <a:t>The Pileの先頭10,000文書を、デバッグ向けに公開した小規模サンプル。本文と構成要素名の形式を試せる。</a:t>
-            </a:r>
-          </a:p>
-        </p:txBody>
-      </p:sp>
-      <p:sp>
-        <p:nvSpPr>
-          <p:cNvPr id="9" name="TextBox 8"/>
-          <p:cNvSpPr txBox="1"/>
-          <p:nvPr/>
-        </p:nvSpPr>
-        <p:spPr>
-          <a:xfrm>
-            <a:off x="594360" y="4163568"/>
             <a:ext cx="7955279" cy="228600"/>
           </a:xfrm>
           <a:prstGeom prst="rect">
@@ -43039,7 +41031,7 @@
                 <a:ea typeface="Noto Sans CJK JP"/>
                 <a:cs typeface="Noto Sans"/>
               </a:rPr>
-              <a:t>前の3例は、内容の違いを示す公開サンプルの抜粋。HELMではテスト文書を使い、長い本文はモデルの文脈長に合わせて分割して採点する。</a:t>
+              <a:t>前の3例は、Web、コード、医学論文という文章の違いを示す公開サンプルの抜粋である。</a:t>
             </a:r>
           </a:p>
         </p:txBody>
@@ -43165,57 +41157,6 @@
                 <a:hlinkClick r:id="rId2"/>
               </a:rPr>
               <a:t>https://arxiv.org/abs/2101.00027</a:t>
-            </a:r>
-          </a:p>
-          <a:p>
-            <a:pPr>
-              <a:lnSpc>
-                <a:spcPts val="940"/>
-              </a:lnSpc>
-              <a:spcAft>
-                <a:spcPts val="140"/>
-              </a:spcAft>
-              <a:buNone/>
-              <a:defRPr sz="810" b="0">
-                <a:solidFill>
-                  <a:srgbClr val="303437"/>
-                </a:solidFill>
-                <a:latin typeface="Noto Sans"/>
-              </a:defRPr>
-            </a:pPr>
-            <a:r>
-              <a:rPr sz="810" b="0" lang="ja-JP" altLang="en-US">
-                <a:solidFill>
-                  <a:srgbClr val="626669"/>
-                </a:solidFill>
-                <a:latin typeface="Noto Sans"/>
-                <a:ea typeface="Noto Sans CJK JP"/>
-                <a:cs typeface="Noto Sans"/>
-              </a:rPr>
-              <a:t>[2] Stanford CRFM. HELM v0.4.0: ThePileScenario.</a:t>
-            </a:r>
-            <a:r>
-              <a:rPr sz="810" b="0" lang="ja-JP" altLang="en-US">
-                <a:solidFill>
-                  <a:srgbClr val="626669"/>
-                </a:solidFill>
-                <a:latin typeface="Noto Sans"/>
-                <a:ea typeface="Noto Sans CJK JP"/>
-                <a:cs typeface="Noto Sans"/>
-              </a:rPr>
-              <a:t>  </a:t>
-            </a:r>
-            <a:r>
-              <a:rPr sz="810" b="0" lang="ja-JP" altLang="en-US">
-                <a:solidFill>
-                  <a:srgbClr val="626669"/>
-                </a:solidFill>
-                <a:latin typeface="Noto Sans"/>
-                <a:ea typeface="Noto Sans CJK JP"/>
-                <a:cs typeface="Noto Sans"/>
-                <a:hlinkClick r:id="rId3"/>
-              </a:rPr>
-              <a:t>https://github.com/stanford-crfm/helm/blob/v0.4.0/src/helm/benchmark/scenarios/the_pile_scenario.py</a:t>
             </a:r>
           </a:p>
         </p:txBody>

</xml_diff>